<commit_message>
Rebuild mobility audit deck in the same format as the preppedbylaurah deck
Co-Authored-By: Claude Opus 5.5 <noreply@anthropic.com>
Claude-Session: https://claude.ai/code/session_01PFnUxwwpVVJDFT6wjHXmsi
</commit_message>
<xml_diff>
--- a/decks/mobility-audit.pptx
+++ b/decks/mobility-audit.pptx
@@ -1391,7 +1391,7 @@
     <p:bg>
       <p:bgPr>
         <a:solidFill>
-          <a:srgbClr val="15202B"/>
+          <a:srgbClr val="1C2620"/>
         </a:solidFill>
       </p:bgPr>
     </p:bg>
@@ -1424,13 +1424,13 @@
             <a:avLst/>
           </a:prstGeom>
           <a:solidFill>
-            <a:srgbClr val="1E8077">
-              <a:alpha val="16000"/>
+            <a:srgbClr val="C8652A">
+              <a:alpha val="14000"/>
             </a:srgbClr>
           </a:solidFill>
           <a:ln w="6350">
             <a:solidFill>
-              <a:srgbClr val="1E8077">
+              <a:srgbClr val="C8652A">
                 <a:alpha val="30000"/>
               </a:srgbClr>
             </a:solidFill>
@@ -1453,13 +1453,13 @@
             <a:avLst/>
           </a:prstGeom>
           <a:solidFill>
-            <a:srgbClr val="1E8077">
-              <a:alpha val="10000"/>
+            <a:srgbClr val="C8652A">
+              <a:alpha val="8000"/>
             </a:srgbClr>
           </a:solidFill>
           <a:ln w="6350">
             <a:solidFill>
-              <a:srgbClr val="15202B"/>
+              <a:srgbClr val="1C2620"/>
             </a:solidFill>
             <a:prstDash val="solid"/>
           </a:ln>
@@ -1473,47 +1473,8 @@
         </p:nvSpPr>
         <p:spPr>
           <a:xfrm>
-            <a:off x="685800" y="1783080"/>
-            <a:ext cx="7315200" cy="274320"/>
-          </a:xfrm>
-          <a:prstGeom prst="rect">
-            <a:avLst/>
-          </a:prstGeom>
-          <a:noFill/>
-          <a:ln/>
-        </p:spPr>
-        <p:txBody>
-          <a:bodyPr wrap="square" lIns="0" tIns="0" rIns="0" bIns="0" rtlCol="0" anchor="ctr"/>
-          <a:lstStyle/>
-          <a:p>
-            <a:pPr indent="0" marL="0">
-              <a:buNone/>
-            </a:pPr>
-            <a:r>
-              <a:rPr lang="en-US" sz="1400" b="1" spc="400" kern="0" dirty="0">
-                <a:solidFill>
-                  <a:srgbClr val="1E8077"/>
-                </a:solidFill>
-                <a:latin typeface="Calibri" pitchFamily="34" charset="0"/>
-                <a:ea typeface="Calibri" pitchFamily="34" charset="-122"/>
-                <a:cs typeface="Calibri" pitchFamily="34" charset="-120"/>
-              </a:rPr>
-              <a:t>MONETISATION AUDIT</a:t>
-            </a:r>
-            <a:endParaRPr lang="en-US" sz="1400" dirty="0"/>
-          </a:p>
-        </p:txBody>
-      </p:sp>
-      <p:sp>
-        <p:nvSpPr>
-          <p:cNvPr id="5" name="Text 3"/>
-          <p:cNvSpPr txBox="1"/>
-          <p:nvPr/>
-        </p:nvSpPr>
-        <p:spPr>
-          <a:xfrm>
-            <a:off x="685800" y="2194560"/>
-            <a:ext cx="7863840" cy="1737360"/>
+            <a:off x="685800" y="2377440"/>
+            <a:ext cx="8229600" cy="1097280"/>
           </a:xfrm>
           <a:prstGeom prst="rect">
             <a:avLst/>
@@ -1526,13 +1487,10 @@
           <a:lstStyle/>
           <a:p>
             <a:pPr indent="0" marL="0">
-              <a:lnSpc>
-                <a:spcPct val="100000"/>
-              </a:lnSpc>
-              <a:buNone/>
-            </a:pPr>
-            <a:r>
-              <a:rPr lang="en-US" sz="5200" b="1" dirty="0">
+              <a:buNone/>
+            </a:pPr>
+            <a:r>
+              <a:rPr lang="en-US" sz="6000" b="1" dirty="0">
                 <a:solidFill>
                   <a:srgbClr val="FFFFFF"/>
                 </a:solidFill>
@@ -1540,54 +1498,15 @@
                 <a:ea typeface="Arial" pitchFamily="34" charset="-122"/>
                 <a:cs typeface="Arial" pitchFamily="34" charset="-120"/>
               </a:rPr>
-              <a:t>Your premium program gameplan</a:t>
-            </a:r>
-            <a:endParaRPr lang="en-US" sz="5200" dirty="0"/>
-          </a:p>
-        </p:txBody>
-      </p:sp>
-      <p:sp>
-        <p:nvSpPr>
-          <p:cNvPr id="6" name="Text 4"/>
-          <p:cNvSpPr txBox="1"/>
-          <p:nvPr/>
-        </p:nvSpPr>
-        <p:spPr>
-          <a:xfrm>
-            <a:off x="685800" y="4069080"/>
-            <a:ext cx="7132320" cy="731520"/>
-          </a:xfrm>
-          <a:prstGeom prst="rect">
-            <a:avLst/>
-          </a:prstGeom>
-          <a:noFill/>
-          <a:ln/>
-        </p:spPr>
-        <p:txBody>
-          <a:bodyPr wrap="square" lIns="0" tIns="0" rIns="0" bIns="0" rtlCol="0" anchor="t"/>
-          <a:lstStyle/>
-          <a:p>
-            <a:pPr indent="0" marL="0">
-              <a:buNone/>
-            </a:pPr>
-            <a:r>
-              <a:rPr lang="en-US" sz="1700" dirty="0">
-                <a:solidFill>
-                  <a:srgbClr val="A7B4BF"/>
-                </a:solidFill>
-                <a:latin typeface="Calibri" pitchFamily="34" charset="0"/>
-                <a:ea typeface="Calibri" pitchFamily="34" charset="-122"/>
-                <a:cs typeface="Calibri" pitchFamily="34" charset="-120"/>
-              </a:rPr>
-              <a:t>The numbers, three product paths, the launch plan, and a test to validate demand.</a:t>
-            </a:r>
-            <a:endParaRPr lang="en-US" sz="1700" dirty="0"/>
-          </a:p>
-        </p:txBody>
-      </p:sp>
-      <p:sp>
-        <p:nvSpPr>
-          <p:cNvPr id="7" name="Text 5"/>
+              <a:t>Monetisation Audit</a:t>
+            </a:r>
+            <a:endParaRPr lang="en-US" sz="6000" dirty="0"/>
+          </a:p>
+        </p:txBody>
+      </p:sp>
+      <p:sp>
+        <p:nvSpPr>
+          <p:cNvPr id="5" name="Text 3"/>
           <p:cNvSpPr txBox="1"/>
           <p:nvPr/>
         </p:nvSpPr>
@@ -1612,7 +1531,7 @@
             <a:r>
               <a:rPr lang="en-US" sz="1200" dirty="0">
                 <a:solidFill>
-                  <a:srgbClr val="A7B4BF"/>
+                  <a:srgbClr val="AEB8AF"/>
                 </a:solidFill>
                 <a:latin typeface="Calibri" pitchFamily="34" charset="0"/>
                 <a:ea typeface="Calibri" pitchFamily="34" charset="-122"/>
@@ -1683,13 +1602,13 @@
             <a:r>
               <a:rPr lang="en-US" sz="1200" b="1" spc="200" kern="0" dirty="0">
                 <a:solidFill>
-                  <a:srgbClr val="1E8077"/>
+                  <a:srgbClr val="C8652A"/>
                 </a:solidFill>
                 <a:latin typeface="Calibri" pitchFamily="34" charset="0"/>
                 <a:ea typeface="Calibri" pitchFamily="34" charset="-122"/>
                 <a:cs typeface="Calibri" pitchFamily="34" charset="-120"/>
               </a:rPr>
-              <a:t>01   THE NUMBERS</a:t>
+              <a:t>03   </a:t>
             </a:r>
             <a:endParaRPr lang="en-US" sz="1200" dirty="0"/>
           </a:p>
@@ -1704,7 +1623,7 @@
         <p:spPr>
           <a:xfrm>
             <a:off x="685800" y="768096"/>
-            <a:ext cx="10820095" cy="640080"/>
+            <a:ext cx="10820095" cy="914400"/>
           </a:xfrm>
           <a:prstGeom prst="rect">
             <a:avLst/>
@@ -1722,13 +1641,13 @@
             <a:r>
               <a:rPr lang="en-US" sz="3200" b="1" dirty="0">
                 <a:solidFill>
-                  <a:srgbClr val="15202B"/>
+                  <a:srgbClr val="1C2620"/>
                 </a:solidFill>
                 <a:latin typeface="Arial" pitchFamily="34" charset="0"/>
                 <a:ea typeface="Arial" pitchFamily="34" charset="-122"/>
                 <a:cs typeface="Arial" pitchFamily="34" charset="-120"/>
               </a:rPr>
-              <a:t>What a small, premium cohort is worth</a:t>
+              <a:t>The Numbers</a:t>
             </a:r>
             <a:endParaRPr lang="en-US" sz="3200" dirty="0"/>
           </a:p>
@@ -1742,20 +1661,20 @@
         </p:nvSpPr>
         <p:spPr>
           <a:xfrm>
-            <a:off x="685800" y="1828800"/>
-            <a:ext cx="3301898" cy="1737360"/>
+            <a:off x="685800" y="2057400"/>
+            <a:ext cx="3350666" cy="1600200"/>
           </a:xfrm>
           <a:prstGeom prst="roundRect">
             <a:avLst>
-              <a:gd name="adj" fmla="val 4737"/>
+              <a:gd name="adj" fmla="val 5143"/>
             </a:avLst>
           </a:prstGeom>
           <a:solidFill>
-            <a:srgbClr val="F0F4F5"/>
+            <a:srgbClr val="F6F2EC"/>
           </a:solidFill>
           <a:ln w="6350">
             <a:solidFill>
-              <a:srgbClr val="F0F4F5"/>
+              <a:srgbClr val="F6F2EC"/>
             </a:solidFill>
             <a:prstDash val="solid"/>
           </a:ln>
@@ -1776,26 +1695,26 @@
         </p:nvSpPr>
         <p:spPr>
           <a:xfrm>
-            <a:off x="1051560" y="2121408"/>
-            <a:ext cx="2570378" cy="640080"/>
-          </a:xfrm>
-          <a:prstGeom prst="rect">
-            <a:avLst/>
-          </a:prstGeom>
-          <a:noFill/>
-          <a:ln/>
-        </p:spPr>
-        <p:txBody>
-          <a:bodyPr wrap="square" lIns="0" tIns="0" rIns="0" bIns="0" rtlCol="0" anchor="ctr"/>
-          <a:lstStyle/>
-          <a:p>
-            <a:pPr indent="0" marL="0">
-              <a:buNone/>
-            </a:pPr>
-            <a:r>
-              <a:rPr lang="en-US" sz="4000" b="1" dirty="0">
-                <a:solidFill>
-                  <a:srgbClr val="1E8077"/>
+            <a:off x="960120" y="2331720"/>
+            <a:ext cx="2802026" cy="548640"/>
+          </a:xfrm>
+          <a:prstGeom prst="rect">
+            <a:avLst/>
+          </a:prstGeom>
+          <a:noFill/>
+          <a:ln/>
+        </p:spPr>
+        <p:txBody>
+          <a:bodyPr wrap="square" lIns="0" tIns="0" rIns="0" bIns="0" rtlCol="0" anchor="ctr"/>
+          <a:lstStyle/>
+          <a:p>
+            <a:pPr indent="0" marL="0">
+              <a:buNone/>
+            </a:pPr>
+            <a:r>
+              <a:rPr lang="en-US" sz="3000" b="1" dirty="0">
+                <a:solidFill>
+                  <a:srgbClr val="C8652A"/>
                 </a:solidFill>
                 <a:latin typeface="Arial" pitchFamily="34" charset="0"/>
                 <a:ea typeface="Arial" pitchFamily="34" charset="-122"/>
@@ -1803,7 +1722,7 @@
               </a:rPr>
               <a:t>747</a:t>
             </a:r>
-            <a:endParaRPr lang="en-US" sz="4000" dirty="0"/>
+            <a:endParaRPr lang="en-US" sz="3000" dirty="0"/>
           </a:p>
         </p:txBody>
       </p:sp>
@@ -1815,26 +1734,26 @@
         </p:nvSpPr>
         <p:spPr>
           <a:xfrm>
-            <a:off x="1051560" y="2834640"/>
-            <a:ext cx="2570378" cy="274320"/>
-          </a:xfrm>
-          <a:prstGeom prst="rect">
-            <a:avLst/>
-          </a:prstGeom>
-          <a:noFill/>
-          <a:ln/>
-        </p:spPr>
-        <p:txBody>
-          <a:bodyPr wrap="square" lIns="0" tIns="0" rIns="0" bIns="0" rtlCol="0" anchor="ctr"/>
-          <a:lstStyle/>
-          <a:p>
-            <a:pPr indent="0" marL="0">
-              <a:buNone/>
-            </a:pPr>
-            <a:r>
-              <a:rPr lang="en-US" sz="1400" b="1" dirty="0">
-                <a:solidFill>
-                  <a:srgbClr val="15202B"/>
+            <a:off x="960120" y="2953512"/>
+            <a:ext cx="2802026" cy="274320"/>
+          </a:xfrm>
+          <a:prstGeom prst="rect">
+            <a:avLst/>
+          </a:prstGeom>
+          <a:noFill/>
+          <a:ln/>
+        </p:spPr>
+        <p:txBody>
+          <a:bodyPr wrap="square" lIns="0" tIns="0" rIns="0" bIns="0" rtlCol="0" anchor="ctr"/>
+          <a:lstStyle/>
+          <a:p>
+            <a:pPr indent="0" marL="0">
+              <a:buNone/>
+            </a:pPr>
+            <a:r>
+              <a:rPr lang="en-US" sz="1300" b="1" dirty="0">
+                <a:solidFill>
+                  <a:srgbClr val="1C2620"/>
                 </a:solidFill>
                 <a:latin typeface="Calibri" pitchFamily="34" charset="0"/>
                 <a:ea typeface="Calibri" pitchFamily="34" charset="-122"/>
@@ -1842,7 +1761,7 @@
               </a:rPr>
               <a:t>Engaged Audience</a:t>
             </a:r>
-            <a:endParaRPr lang="en-US" sz="1400" dirty="0"/>
+            <a:endParaRPr lang="en-US" sz="1300" dirty="0"/>
           </a:p>
         </p:txBody>
       </p:sp>
@@ -1854,26 +1773,26 @@
         </p:nvSpPr>
         <p:spPr>
           <a:xfrm>
-            <a:off x="1051560" y="3127248"/>
-            <a:ext cx="2570378" cy="256032"/>
-          </a:xfrm>
-          <a:prstGeom prst="rect">
-            <a:avLst/>
-          </a:prstGeom>
-          <a:noFill/>
-          <a:ln/>
-        </p:spPr>
-        <p:txBody>
-          <a:bodyPr wrap="square" lIns="0" tIns="0" rIns="0" bIns="0" rtlCol="0" anchor="ctr"/>
-          <a:lstStyle/>
-          <a:p>
-            <a:pPr indent="0" marL="0">
-              <a:buNone/>
-            </a:pPr>
-            <a:r>
-              <a:rPr lang="en-US" sz="1200" dirty="0">
-                <a:solidFill>
-                  <a:srgbClr val="5B6670"/>
+            <a:off x="960120" y="3227832"/>
+            <a:ext cx="2802026" cy="256032"/>
+          </a:xfrm>
+          <a:prstGeom prst="rect">
+            <a:avLst/>
+          </a:prstGeom>
+          <a:noFill/>
+          <a:ln/>
+        </p:spPr>
+        <p:txBody>
+          <a:bodyPr wrap="square" lIns="0" tIns="0" rIns="0" bIns="0" rtlCol="0" anchor="ctr"/>
+          <a:lstStyle/>
+          <a:p>
+            <a:pPr indent="0" marL="0">
+              <a:buNone/>
+            </a:pPr>
+            <a:r>
+              <a:rPr lang="en-US" sz="1100" dirty="0">
+                <a:solidFill>
+                  <a:srgbClr val="5F665F"/>
                 </a:solidFill>
                 <a:latin typeface="Calibri" pitchFamily="34" charset="0"/>
                 <a:ea typeface="Calibri" pitchFamily="34" charset="-122"/>
@@ -1881,7 +1800,7 @@
               </a:rPr>
               <a:t>5% market premise</a:t>
             </a:r>
-            <a:endParaRPr lang="en-US" sz="1200" dirty="0"/>
+            <a:endParaRPr lang="en-US" sz="1100" dirty="0"/>
           </a:p>
         </p:txBody>
       </p:sp>
@@ -1893,8 +1812,8 @@
         </p:nvSpPr>
         <p:spPr>
           <a:xfrm>
-            <a:off x="3987698" y="2468880"/>
-            <a:ext cx="457200" cy="457200"/>
+            <a:off x="4036466" y="2628900"/>
+            <a:ext cx="384048" cy="457200"/>
           </a:xfrm>
           <a:prstGeom prst="rect">
             <a:avLst/>
@@ -1910,9 +1829,9 @@
               <a:buNone/>
             </a:pPr>
             <a:r>
-              <a:rPr lang="en-US" sz="2000" dirty="0">
-                <a:solidFill>
-                  <a:srgbClr val="1E8077"/>
+              <a:rPr lang="en-US" sz="1800" dirty="0">
+                <a:solidFill>
+                  <a:srgbClr val="C8652A"/>
                 </a:solidFill>
                 <a:latin typeface="Arial" pitchFamily="34" charset="0"/>
                 <a:ea typeface="Arial" pitchFamily="34" charset="-122"/>
@@ -1920,7 +1839,7 @@
               </a:rPr>
               <a:t>→</a:t>
             </a:r>
-            <a:endParaRPr lang="en-US" sz="2000" dirty="0"/>
+            <a:endParaRPr lang="en-US" sz="1800" dirty="0"/>
           </a:p>
         </p:txBody>
       </p:sp>
@@ -1932,20 +1851,20 @@
         </p:nvSpPr>
         <p:spPr>
           <a:xfrm>
-            <a:off x="4444898" y="1828800"/>
-            <a:ext cx="3301898" cy="1737360"/>
+            <a:off x="4420514" y="2057400"/>
+            <a:ext cx="3350666" cy="1600200"/>
           </a:xfrm>
           <a:prstGeom prst="roundRect">
             <a:avLst>
-              <a:gd name="adj" fmla="val 4737"/>
+              <a:gd name="adj" fmla="val 5143"/>
             </a:avLst>
           </a:prstGeom>
           <a:solidFill>
-            <a:srgbClr val="F0F4F5"/>
+            <a:srgbClr val="F6F2EC"/>
           </a:solidFill>
           <a:ln w="6350">
             <a:solidFill>
-              <a:srgbClr val="F0F4F5"/>
+              <a:srgbClr val="F6F2EC"/>
             </a:solidFill>
             <a:prstDash val="solid"/>
           </a:ln>
@@ -1966,26 +1885,26 @@
         </p:nvSpPr>
         <p:spPr>
           <a:xfrm>
-            <a:off x="4810658" y="2121408"/>
-            <a:ext cx="2570378" cy="640080"/>
-          </a:xfrm>
-          <a:prstGeom prst="rect">
-            <a:avLst/>
-          </a:prstGeom>
-          <a:noFill/>
-          <a:ln/>
-        </p:spPr>
-        <p:txBody>
-          <a:bodyPr wrap="square" lIns="0" tIns="0" rIns="0" bIns="0" rtlCol="0" anchor="ctr"/>
-          <a:lstStyle/>
-          <a:p>
-            <a:pPr indent="0" marL="0">
-              <a:buNone/>
-            </a:pPr>
-            <a:r>
-              <a:rPr lang="en-US" sz="4000" b="1" dirty="0">
-                <a:solidFill>
-                  <a:srgbClr val="1E8077"/>
+            <a:off x="4694834" y="2331720"/>
+            <a:ext cx="2802026" cy="548640"/>
+          </a:xfrm>
+          <a:prstGeom prst="rect">
+            <a:avLst/>
+          </a:prstGeom>
+          <a:noFill/>
+          <a:ln/>
+        </p:spPr>
+        <p:txBody>
+          <a:bodyPr wrap="square" lIns="0" tIns="0" rIns="0" bIns="0" rtlCol="0" anchor="ctr"/>
+          <a:lstStyle/>
+          <a:p>
+            <a:pPr indent="0" marL="0">
+              <a:buNone/>
+            </a:pPr>
+            <a:r>
+              <a:rPr lang="en-US" sz="3000" b="1" dirty="0">
+                <a:solidFill>
+                  <a:srgbClr val="C8652A"/>
                 </a:solidFill>
                 <a:latin typeface="Arial" pitchFamily="34" charset="0"/>
                 <a:ea typeface="Arial" pitchFamily="34" charset="-122"/>
@@ -1993,7 +1912,7 @@
               </a:rPr>
               <a:t>20</a:t>
             </a:r>
-            <a:endParaRPr lang="en-US" sz="4000" dirty="0"/>
+            <a:endParaRPr lang="en-US" sz="3000" dirty="0"/>
           </a:p>
         </p:txBody>
       </p:sp>
@@ -2005,26 +1924,26 @@
         </p:nvSpPr>
         <p:spPr>
           <a:xfrm>
-            <a:off x="4810658" y="2834640"/>
-            <a:ext cx="2570378" cy="274320"/>
-          </a:xfrm>
-          <a:prstGeom prst="rect">
-            <a:avLst/>
-          </a:prstGeom>
-          <a:noFill/>
-          <a:ln/>
-        </p:spPr>
-        <p:txBody>
-          <a:bodyPr wrap="square" lIns="0" tIns="0" rIns="0" bIns="0" rtlCol="0" anchor="ctr"/>
-          <a:lstStyle/>
-          <a:p>
-            <a:pPr indent="0" marL="0">
-              <a:buNone/>
-            </a:pPr>
-            <a:r>
-              <a:rPr lang="en-US" sz="1400" b="1" dirty="0">
-                <a:solidFill>
-                  <a:srgbClr val="15202B"/>
+            <a:off x="4694834" y="2953512"/>
+            <a:ext cx="2802026" cy="274320"/>
+          </a:xfrm>
+          <a:prstGeom prst="rect">
+            <a:avLst/>
+          </a:prstGeom>
+          <a:noFill/>
+          <a:ln/>
+        </p:spPr>
+        <p:txBody>
+          <a:bodyPr wrap="square" lIns="0" tIns="0" rIns="0" bIns="0" rtlCol="0" anchor="ctr"/>
+          <a:lstStyle/>
+          <a:p>
+            <a:pPr indent="0" marL="0">
+              <a:buNone/>
+            </a:pPr>
+            <a:r>
+              <a:rPr lang="en-US" sz="1300" b="1" dirty="0">
+                <a:solidFill>
+                  <a:srgbClr val="1C2620"/>
                 </a:solidFill>
                 <a:latin typeface="Calibri" pitchFamily="34" charset="0"/>
                 <a:ea typeface="Calibri" pitchFamily="34" charset="-122"/>
@@ -2032,7 +1951,7 @@
               </a:rPr>
               <a:t>Program Spots</a:t>
             </a:r>
-            <a:endParaRPr lang="en-US" sz="1400" dirty="0"/>
+            <a:endParaRPr lang="en-US" sz="1300" dirty="0"/>
           </a:p>
         </p:txBody>
       </p:sp>
@@ -2044,26 +1963,26 @@
         </p:nvSpPr>
         <p:spPr>
           <a:xfrm>
-            <a:off x="4810658" y="3127248"/>
-            <a:ext cx="2570378" cy="256032"/>
-          </a:xfrm>
-          <a:prstGeom prst="rect">
-            <a:avLst/>
-          </a:prstGeom>
-          <a:noFill/>
-          <a:ln/>
-        </p:spPr>
-        <p:txBody>
-          <a:bodyPr wrap="square" lIns="0" tIns="0" rIns="0" bIns="0" rtlCol="0" anchor="ctr"/>
-          <a:lstStyle/>
-          <a:p>
-            <a:pPr indent="0" marL="0">
-              <a:buNone/>
-            </a:pPr>
-            <a:r>
-              <a:rPr lang="en-US" sz="1200" dirty="0">
-                <a:solidFill>
-                  <a:srgbClr val="5B6670"/>
+            <a:off x="4694834" y="3227832"/>
+            <a:ext cx="2802026" cy="256032"/>
+          </a:xfrm>
+          <a:prstGeom prst="rect">
+            <a:avLst/>
+          </a:prstGeom>
+          <a:noFill/>
+          <a:ln/>
+        </p:spPr>
+        <p:txBody>
+          <a:bodyPr wrap="square" lIns="0" tIns="0" rIns="0" bIns="0" rtlCol="0" anchor="ctr"/>
+          <a:lstStyle/>
+          <a:p>
+            <a:pPr indent="0" marL="0">
+              <a:buNone/>
+            </a:pPr>
+            <a:r>
+              <a:rPr lang="en-US" sz="1100" dirty="0">
+                <a:solidFill>
+                  <a:srgbClr val="5F665F"/>
                 </a:solidFill>
                 <a:latin typeface="Calibri" pitchFamily="34" charset="0"/>
                 <a:ea typeface="Calibri" pitchFamily="34" charset="-122"/>
@@ -2071,7 +1990,7 @@
               </a:rPr>
               <a:t>Deliberately limited</a:t>
             </a:r>
-            <a:endParaRPr lang="en-US" sz="1200" dirty="0"/>
+            <a:endParaRPr lang="en-US" sz="1100" dirty="0"/>
           </a:p>
         </p:txBody>
       </p:sp>
@@ -2083,8 +2002,8 @@
         </p:nvSpPr>
         <p:spPr>
           <a:xfrm>
-            <a:off x="7746797" y="2468880"/>
-            <a:ext cx="457200" cy="457200"/>
+            <a:off x="7771181" y="2628900"/>
+            <a:ext cx="384048" cy="457200"/>
           </a:xfrm>
           <a:prstGeom prst="rect">
             <a:avLst/>
@@ -2100,9 +2019,9 @@
               <a:buNone/>
             </a:pPr>
             <a:r>
-              <a:rPr lang="en-US" sz="2000" dirty="0">
-                <a:solidFill>
-                  <a:srgbClr val="1E8077"/>
+              <a:rPr lang="en-US" sz="1800" dirty="0">
+                <a:solidFill>
+                  <a:srgbClr val="C8652A"/>
                 </a:solidFill>
                 <a:latin typeface="Arial" pitchFamily="34" charset="0"/>
                 <a:ea typeface="Arial" pitchFamily="34" charset="-122"/>
@@ -2110,7 +2029,7 @@
               </a:rPr>
               <a:t>→</a:t>
             </a:r>
-            <a:endParaRPr lang="en-US" sz="2000" dirty="0"/>
+            <a:endParaRPr lang="en-US" sz="1800" dirty="0"/>
           </a:p>
         </p:txBody>
       </p:sp>
@@ -2122,20 +2041,20 @@
         </p:nvSpPr>
         <p:spPr>
           <a:xfrm>
-            <a:off x="8203997" y="1828800"/>
-            <a:ext cx="3301898" cy="1737360"/>
+            <a:off x="8155229" y="2057400"/>
+            <a:ext cx="3350666" cy="1600200"/>
           </a:xfrm>
           <a:prstGeom prst="roundRect">
             <a:avLst>
-              <a:gd name="adj" fmla="val 4737"/>
+              <a:gd name="adj" fmla="val 5143"/>
             </a:avLst>
           </a:prstGeom>
           <a:solidFill>
-            <a:srgbClr val="F0F4F5"/>
+            <a:srgbClr val="F6F2EC"/>
           </a:solidFill>
           <a:ln w="6350">
             <a:solidFill>
-              <a:srgbClr val="F0F4F5"/>
+              <a:srgbClr val="F6F2EC"/>
             </a:solidFill>
             <a:prstDash val="solid"/>
           </a:ln>
@@ -2156,26 +2075,26 @@
         </p:nvSpPr>
         <p:spPr>
           <a:xfrm>
-            <a:off x="8569757" y="2121408"/>
-            <a:ext cx="2570378" cy="640080"/>
-          </a:xfrm>
-          <a:prstGeom prst="rect">
-            <a:avLst/>
-          </a:prstGeom>
-          <a:noFill/>
-          <a:ln/>
-        </p:spPr>
-        <p:txBody>
-          <a:bodyPr wrap="square" lIns="0" tIns="0" rIns="0" bIns="0" rtlCol="0" anchor="ctr"/>
-          <a:lstStyle/>
-          <a:p>
-            <a:pPr indent="0" marL="0">
-              <a:buNone/>
-            </a:pPr>
-            <a:r>
-              <a:rPr lang="en-US" sz="4000" b="1" dirty="0">
-                <a:solidFill>
-                  <a:srgbClr val="1E8077"/>
+            <a:off x="8429549" y="2331720"/>
+            <a:ext cx="2802026" cy="548640"/>
+          </a:xfrm>
+          <a:prstGeom prst="rect">
+            <a:avLst/>
+          </a:prstGeom>
+          <a:noFill/>
+          <a:ln/>
+        </p:spPr>
+        <p:txBody>
+          <a:bodyPr wrap="square" lIns="0" tIns="0" rIns="0" bIns="0" rtlCol="0" anchor="ctr"/>
+          <a:lstStyle/>
+          <a:p>
+            <a:pPr indent="0" marL="0">
+              <a:buNone/>
+            </a:pPr>
+            <a:r>
+              <a:rPr lang="en-US" sz="3000" b="1" dirty="0">
+                <a:solidFill>
+                  <a:srgbClr val="C8652A"/>
                 </a:solidFill>
                 <a:latin typeface="Arial" pitchFamily="34" charset="0"/>
                 <a:ea typeface="Arial" pitchFamily="34" charset="-122"/>
@@ -2183,7 +2102,7 @@
               </a:rPr>
               <a:t>$1,500</a:t>
             </a:r>
-            <a:endParaRPr lang="en-US" sz="4000" dirty="0"/>
+            <a:endParaRPr lang="en-US" sz="3000" dirty="0"/>
           </a:p>
         </p:txBody>
       </p:sp>
@@ -2195,26 +2114,26 @@
         </p:nvSpPr>
         <p:spPr>
           <a:xfrm>
-            <a:off x="8569757" y="2834640"/>
-            <a:ext cx="2570378" cy="274320"/>
-          </a:xfrm>
-          <a:prstGeom prst="rect">
-            <a:avLst/>
-          </a:prstGeom>
-          <a:noFill/>
-          <a:ln/>
-        </p:spPr>
-        <p:txBody>
-          <a:bodyPr wrap="square" lIns="0" tIns="0" rIns="0" bIns="0" rtlCol="0" anchor="ctr"/>
-          <a:lstStyle/>
-          <a:p>
-            <a:pPr indent="0" marL="0">
-              <a:buNone/>
-            </a:pPr>
-            <a:r>
-              <a:rPr lang="en-US" sz="1400" b="1" dirty="0">
-                <a:solidFill>
-                  <a:srgbClr val="15202B"/>
+            <a:off x="8429549" y="2953512"/>
+            <a:ext cx="2802026" cy="274320"/>
+          </a:xfrm>
+          <a:prstGeom prst="rect">
+            <a:avLst/>
+          </a:prstGeom>
+          <a:noFill/>
+          <a:ln/>
+        </p:spPr>
+        <p:txBody>
+          <a:bodyPr wrap="square" lIns="0" tIns="0" rIns="0" bIns="0" rtlCol="0" anchor="ctr"/>
+          <a:lstStyle/>
+          <a:p>
+            <a:pPr indent="0" marL="0">
+              <a:buNone/>
+            </a:pPr>
+            <a:r>
+              <a:rPr lang="en-US" sz="1300" b="1" dirty="0">
+                <a:solidFill>
+                  <a:srgbClr val="1C2620"/>
                 </a:solidFill>
                 <a:latin typeface="Calibri" pitchFamily="34" charset="0"/>
                 <a:ea typeface="Calibri" pitchFamily="34" charset="-122"/>
@@ -2222,7 +2141,7 @@
               </a:rPr>
               <a:t>Product Price</a:t>
             </a:r>
-            <a:endParaRPr lang="en-US" sz="1400" dirty="0"/>
+            <a:endParaRPr lang="en-US" sz="1300" dirty="0"/>
           </a:p>
         </p:txBody>
       </p:sp>
@@ -2253,7 +2172,7 @@
             <a:r>
               <a:rPr lang="en-US" sz="1100" b="1" spc="200" kern="0" dirty="0">
                 <a:solidFill>
-                  <a:srgbClr val="1E8077"/>
+                  <a:srgbClr val="C8652A"/>
                 </a:solidFill>
                 <a:latin typeface="Calibri" pitchFamily="34" charset="0"/>
                 <a:ea typeface="Calibri" pitchFamily="34" charset="-122"/>
@@ -2274,19 +2193,19 @@
         <p:spPr>
           <a:xfrm>
             <a:off x="685800" y="4343400"/>
-            <a:ext cx="10820095" cy="1005840"/>
+            <a:ext cx="10820095" cy="640080"/>
           </a:xfrm>
           <a:prstGeom prst="roundRect">
             <a:avLst>
-              <a:gd name="adj" fmla="val 8182"/>
+              <a:gd name="adj" fmla="val 12857"/>
             </a:avLst>
           </a:prstGeom>
           <a:solidFill>
-            <a:srgbClr val="DCEDEB"/>
+            <a:srgbClr val="F3E3D6"/>
           </a:solidFill>
           <a:ln w="6350">
             <a:solidFill>
-              <a:srgbClr val="DCEDEB"/>
+              <a:srgbClr val="F3E3D6"/>
             </a:solidFill>
             <a:prstDash val="solid"/>
           </a:ln>
@@ -2307,73 +2226,73 @@
         </p:nvSpPr>
         <p:spPr>
           <a:xfrm>
-            <a:off x="1143000" y="4343400"/>
-            <a:ext cx="5486400" cy="1005840"/>
-          </a:xfrm>
-          <a:prstGeom prst="rect">
-            <a:avLst/>
-          </a:prstGeom>
-          <a:noFill/>
-          <a:ln/>
-        </p:spPr>
-        <p:txBody>
-          <a:bodyPr wrap="square" lIns="0" tIns="0" rIns="0" bIns="0" rtlCol="0" anchor="ctr"/>
-          <a:lstStyle/>
-          <a:p>
-            <a:pPr indent="0" marL="0">
-              <a:buNone/>
-            </a:pPr>
-            <a:r>
-              <a:rPr lang="en-US" sz="2600" b="1" dirty="0">
-                <a:solidFill>
-                  <a:srgbClr val="15202B"/>
+            <a:off x="1051560" y="4343400"/>
+            <a:ext cx="5486400" cy="640080"/>
+          </a:xfrm>
+          <a:prstGeom prst="rect">
+            <a:avLst/>
+          </a:prstGeom>
+          <a:noFill/>
+          <a:ln/>
+        </p:spPr>
+        <p:txBody>
+          <a:bodyPr wrap="square" lIns="0" tIns="0" rIns="0" bIns="0" rtlCol="0" anchor="ctr"/>
+          <a:lstStyle/>
+          <a:p>
+            <a:pPr indent="0" marL="0">
+              <a:buNone/>
+            </a:pPr>
+            <a:r>
+              <a:rPr lang="en-US" sz="1500" dirty="0">
+                <a:solidFill>
+                  <a:srgbClr val="5F665F"/>
+                </a:solidFill>
+                <a:latin typeface="Calibri" pitchFamily="34" charset="0"/>
+                <a:ea typeface="Calibri" pitchFamily="34" charset="-122"/>
+                <a:cs typeface="Calibri" pitchFamily="34" charset="-120"/>
+              </a:rPr>
+              <a:t>20 spots  ×  $1,500</a:t>
+            </a:r>
+            <a:endParaRPr lang="en-US" sz="1500" dirty="0"/>
+          </a:p>
+        </p:txBody>
+      </p:sp>
+      <p:sp>
+        <p:nvSpPr>
+          <p:cNvPr id="20" name="Text 18"/>
+          <p:cNvSpPr txBox="1"/>
+          <p:nvPr/>
+        </p:nvSpPr>
+        <p:spPr>
+          <a:xfrm>
+            <a:off x="8396935" y="4343400"/>
+            <a:ext cx="2743200" cy="640080"/>
+          </a:xfrm>
+          <a:prstGeom prst="rect">
+            <a:avLst/>
+          </a:prstGeom>
+          <a:noFill/>
+          <a:ln/>
+        </p:spPr>
+        <p:txBody>
+          <a:bodyPr wrap="square" lIns="0" tIns="0" rIns="0" bIns="0" rtlCol="0" anchor="ctr"/>
+          <a:lstStyle/>
+          <a:p>
+            <a:pPr algn="r" indent="0" marL="0">
+              <a:buNone/>
+            </a:pPr>
+            <a:r>
+              <a:rPr lang="en-US" sz="2000" b="1" dirty="0">
+                <a:solidFill>
+                  <a:srgbClr val="C8652A"/>
                 </a:solidFill>
                 <a:latin typeface="Arial" pitchFamily="34" charset="0"/>
                 <a:ea typeface="Arial" pitchFamily="34" charset="-122"/>
                 <a:cs typeface="Arial" pitchFamily="34" charset="-120"/>
               </a:rPr>
-              <a:t>20 spots  ×  $1,500</a:t>
-            </a:r>
-            <a:endParaRPr lang="en-US" sz="2600" dirty="0"/>
-          </a:p>
-        </p:txBody>
-      </p:sp>
-      <p:sp>
-        <p:nvSpPr>
-          <p:cNvPr id="20" name="Text 18"/>
-          <p:cNvSpPr txBox="1"/>
-          <p:nvPr/>
-        </p:nvSpPr>
-        <p:spPr>
-          <a:xfrm>
-            <a:off x="6933895" y="4343400"/>
-            <a:ext cx="4114800" cy="1005840"/>
-          </a:xfrm>
-          <a:prstGeom prst="rect">
-            <a:avLst/>
-          </a:prstGeom>
-          <a:noFill/>
-          <a:ln/>
-        </p:spPr>
-        <p:txBody>
-          <a:bodyPr wrap="square" lIns="0" tIns="0" rIns="0" bIns="0" rtlCol="0" anchor="ctr"/>
-          <a:lstStyle/>
-          <a:p>
-            <a:pPr algn="r" indent="0" marL="0">
-              <a:buNone/>
-            </a:pPr>
-            <a:r>
-              <a:rPr lang="en-US" sz="3400" b="1" dirty="0">
-                <a:solidFill>
-                  <a:srgbClr val="1E8077"/>
-                </a:solidFill>
-                <a:latin typeface="Arial" pitchFamily="34" charset="0"/>
-                <a:ea typeface="Arial" pitchFamily="34" charset="-122"/>
-                <a:cs typeface="Arial" pitchFamily="34" charset="-120"/>
-              </a:rPr>
               <a:t>= $30,000</a:t>
             </a:r>
-            <a:endParaRPr lang="en-US" sz="3400" dirty="0"/>
+            <a:endParaRPr lang="en-US" sz="2000" dirty="0"/>
           </a:p>
         </p:txBody>
       </p:sp>
@@ -2404,13 +2323,13 @@
             <a:r>
               <a:rPr lang="en-US" sz="1000" dirty="0">
                 <a:solidFill>
-                  <a:srgbClr val="5B6670"/>
+                  <a:srgbClr val="5F665F"/>
                 </a:solidFill>
                 <a:latin typeface="Calibri" pitchFamily="34" charset="0"/>
                 <a:ea typeface="Calibri" pitchFamily="34" charset="-122"/>
                 <a:cs typeface="Calibri" pitchFamily="34" charset="-120"/>
               </a:rPr>
-              <a:t>Prepared by Sean</a:t>
+              <a:t>Sean</a:t>
             </a:r>
             <a:endParaRPr lang="en-US" sz="1000" dirty="0"/>
           </a:p>
@@ -2443,7 +2362,7 @@
             <a:r>
               <a:rPr lang="en-US" sz="1000" dirty="0">
                 <a:solidFill>
-                  <a:srgbClr val="5B6670"/>
+                  <a:srgbClr val="5F665F"/>
                 </a:solidFill>
                 <a:latin typeface="Calibri" pitchFamily="34" charset="0"/>
                 <a:ea typeface="Calibri" pitchFamily="34" charset="-122"/>
@@ -2469,7 +2388,7 @@
     <p:bg>
       <p:bgPr>
         <a:solidFill>
-          <a:srgbClr val="15202B"/>
+          <a:srgbClr val="1C2620"/>
         </a:solidFill>
       </p:bgPr>
     </p:bg>
@@ -2502,13 +2421,13 @@
             <a:avLst/>
           </a:prstGeom>
           <a:solidFill>
-            <a:srgbClr val="1E8077">
-              <a:alpha val="14000"/>
+            <a:srgbClr val="C8652A">
+              <a:alpha val="12000"/>
             </a:srgbClr>
           </a:solidFill>
           <a:ln w="6350">
             <a:solidFill>
-              <a:srgbClr val="1E8077">
+              <a:srgbClr val="C8652A">
                 <a:alpha val="30000"/>
               </a:srgbClr>
             </a:solidFill>
@@ -2543,7 +2462,7 @@
             <a:r>
               <a:rPr lang="en-US" sz="1300" b="1" spc="400" kern="0" dirty="0">
                 <a:solidFill>
-                  <a:srgbClr val="1E8077"/>
+                  <a:srgbClr val="C8652A"/>
                 </a:solidFill>
                 <a:latin typeface="Calibri" pitchFamily="34" charset="0"/>
                 <a:ea typeface="Calibri" pitchFamily="34" charset="-122"/>
@@ -2564,23 +2483,23 @@
         <p:spPr>
           <a:xfrm>
             <a:off x="685800" y="1828800"/>
-            <a:ext cx="10820095" cy="1280160"/>
-          </a:xfrm>
-          <a:prstGeom prst="rect">
-            <a:avLst/>
-          </a:prstGeom>
-          <a:noFill/>
-          <a:ln/>
-        </p:spPr>
-        <p:txBody>
-          <a:bodyPr wrap="square" lIns="0" tIns="0" rIns="0" bIns="0" rtlCol="0" anchor="ctr"/>
-          <a:lstStyle/>
-          <a:p>
-            <a:pPr indent="0" marL="0">
-              <a:buNone/>
-            </a:pPr>
-            <a:r>
-              <a:rPr lang="en-US" sz="8000" b="1" dirty="0">
+            <a:ext cx="10820095" cy="1188720"/>
+          </a:xfrm>
+          <a:prstGeom prst="rect">
+            <a:avLst/>
+          </a:prstGeom>
+          <a:noFill/>
+          <a:ln/>
+        </p:spPr>
+        <p:txBody>
+          <a:bodyPr wrap="square" lIns="0" tIns="0" rIns="0" bIns="0" rtlCol="0" anchor="ctr"/>
+          <a:lstStyle/>
+          <a:p>
+            <a:pPr indent="0" marL="0">
+              <a:buNone/>
+            </a:pPr>
+            <a:r>
+              <a:rPr lang="en-US" sz="6000" b="1" dirty="0">
                 <a:solidFill>
                   <a:srgbClr val="FFFFFF"/>
                 </a:solidFill>
@@ -2590,21 +2509,7 @@
               </a:rPr>
               <a:t>$30,000</a:t>
             </a:r>
-            <a:pPr indent="0" marL="0">
-              <a:buNone/>
-            </a:pPr>
-            <a:r>
-              <a:rPr lang="en-US" sz="2600" b="1" dirty="0">
-                <a:solidFill>
-                  <a:srgbClr val="A7B4BF"/>
-                </a:solidFill>
-                <a:latin typeface="Arial" pitchFamily="34" charset="0"/>
-                <a:ea typeface="Arial" pitchFamily="34" charset="-122"/>
-                <a:cs typeface="Arial" pitchFamily="34" charset="-120"/>
-              </a:rPr>
-              <a:t>  per cohort</a:t>
-            </a:r>
-            <a:endParaRPr lang="en-US" sz="8000" dirty="0"/>
+            <a:endParaRPr lang="en-US" sz="6000" dirty="0"/>
           </a:p>
         </p:txBody>
       </p:sp>
@@ -2616,18 +2521,18 @@
         </p:nvSpPr>
         <p:spPr>
           <a:xfrm>
-            <a:off x="685800" y="3337560"/>
+            <a:off x="685800" y="3291840"/>
             <a:ext cx="1005840" cy="54864"/>
           </a:xfrm>
           <a:prstGeom prst="rect">
             <a:avLst/>
           </a:prstGeom>
           <a:solidFill>
-            <a:srgbClr val="1E8077"/>
+            <a:srgbClr val="C8652A"/>
           </a:solidFill>
           <a:ln w="12700">
             <a:solidFill>
-              <a:srgbClr val="1E8077"/>
+              <a:srgbClr val="C8652A"/>
             </a:solidFill>
             <a:prstDash val="solid"/>
           </a:ln>
@@ -2641,7 +2546,7 @@
         </p:nvSpPr>
         <p:spPr>
           <a:xfrm>
-            <a:off x="685800" y="3657600"/>
+            <a:off x="685800" y="3611880"/>
             <a:ext cx="8778240" cy="1188720"/>
           </a:xfrm>
           <a:prstGeom prst="rect">
@@ -2663,7 +2568,7 @@
             <a:r>
               <a:rPr lang="en-US" sz="2200" dirty="0">
                 <a:solidFill>
-                  <a:srgbClr val="A7B4BF"/>
+                  <a:srgbClr val="AEB8AF"/>
                 </a:solidFill>
                 <a:latin typeface="Calibri" pitchFamily="34" charset="0"/>
                 <a:ea typeface="Calibri" pitchFamily="34" charset="-122"/>
@@ -2680,7 +2585,7 @@
             <a:r>
               <a:rPr lang="en-US" sz="2200" b="1" dirty="0">
                 <a:solidFill>
-                  <a:srgbClr val="5FC4B8"/>
+                  <a:srgbClr val="C8652A"/>
                 </a:solidFill>
                 <a:latin typeface="Calibri" pitchFamily="34" charset="0"/>
                 <a:ea typeface="Calibri" pitchFamily="34" charset="-122"/>
@@ -2697,7 +2602,7 @@
             <a:r>
               <a:rPr lang="en-US" sz="2200" dirty="0">
                 <a:solidFill>
-                  <a:srgbClr val="A7B4BF"/>
+                  <a:srgbClr val="AEB8AF"/>
                 </a:solidFill>
                 <a:latin typeface="Calibri" pitchFamily="34" charset="0"/>
                 <a:ea typeface="Calibri" pitchFamily="34" charset="-122"/>
@@ -2736,13 +2641,13 @@
             <a:r>
               <a:rPr lang="en-US" sz="1000" dirty="0">
                 <a:solidFill>
-                  <a:srgbClr val="A7B4BF"/>
+                  <a:srgbClr val="AEB8AF"/>
                 </a:solidFill>
                 <a:latin typeface="Calibri" pitchFamily="34" charset="0"/>
                 <a:ea typeface="Calibri" pitchFamily="34" charset="-122"/>
                 <a:cs typeface="Calibri" pitchFamily="34" charset="-120"/>
               </a:rPr>
-              <a:t>Prepared by Sean</a:t>
+              <a:t>Sean</a:t>
             </a:r>
             <a:endParaRPr lang="en-US" sz="1000" dirty="0"/>
           </a:p>
@@ -2775,7 +2680,7 @@
             <a:r>
               <a:rPr lang="en-US" sz="1000" dirty="0">
                 <a:solidFill>
-                  <a:srgbClr val="A7B4BF"/>
+                  <a:srgbClr val="AEB8AF"/>
                 </a:solidFill>
                 <a:latin typeface="Calibri" pitchFamily="34" charset="0"/>
                 <a:ea typeface="Calibri" pitchFamily="34" charset="-122"/>
@@ -2846,13 +2751,13 @@
             <a:r>
               <a:rPr lang="en-US" sz="1200" b="1" spc="200" kern="0" dirty="0">
                 <a:solidFill>
-                  <a:srgbClr val="1E8077"/>
+                  <a:srgbClr val="C8652A"/>
                 </a:solidFill>
                 <a:latin typeface="Calibri" pitchFamily="34" charset="0"/>
                 <a:ea typeface="Calibri" pitchFamily="34" charset="-122"/>
                 <a:cs typeface="Calibri" pitchFamily="34" charset="-120"/>
               </a:rPr>
-              <a:t>02   PRODUCT SUGGESTIONS</a:t>
+              <a:t>04   PRODUCT SUGGESTIONS</a:t>
             </a:r>
             <a:endParaRPr lang="en-US" sz="1200" dirty="0"/>
           </a:p>
@@ -2867,7 +2772,7 @@
         <p:spPr>
           <a:xfrm>
             <a:off x="685800" y="768096"/>
-            <a:ext cx="10820095" cy="640080"/>
+            <a:ext cx="10820095" cy="914400"/>
           </a:xfrm>
           <a:prstGeom prst="rect">
             <a:avLst/>
@@ -2885,7 +2790,7 @@
             <a:r>
               <a:rPr lang="en-US" sz="3200" b="1" dirty="0">
                 <a:solidFill>
-                  <a:srgbClr val="15202B"/>
+                  <a:srgbClr val="1C2620"/>
                 </a:solidFill>
                 <a:latin typeface="Arial" pitchFamily="34" charset="0"/>
                 <a:ea typeface="Arial" pitchFamily="34" charset="-122"/>
@@ -2924,7 +2829,7 @@
             <a:r>
               <a:rPr lang="en-US" sz="1300" dirty="0">
                 <a:solidFill>
-                  <a:srgbClr val="5B6670"/>
+                  <a:srgbClr val="5F665F"/>
                 </a:solidFill>
                 <a:latin typeface="Calibri" pitchFamily="34" charset="0"/>
                 <a:ea typeface="Calibri" pitchFamily="34" charset="-122"/>
@@ -2944,7 +2849,7 @@
         </p:nvSpPr>
         <p:spPr>
           <a:xfrm>
-            <a:off x="9905695" y="457200"/>
+            <a:off x="9905695" y="438912"/>
             <a:ext cx="1417320" cy="292608"/>
           </a:xfrm>
           <a:prstGeom prst="roundRect">
@@ -2953,11 +2858,11 @@
             </a:avLst>
           </a:prstGeom>
           <a:solidFill>
-            <a:srgbClr val="1E8077"/>
+            <a:srgbClr val="C8652A"/>
           </a:solidFill>
           <a:ln w="6350">
             <a:solidFill>
-              <a:srgbClr val="1E8077"/>
+              <a:srgbClr val="C8652A"/>
             </a:solidFill>
             <a:prstDash val="solid"/>
           </a:ln>
@@ -2971,7 +2876,7 @@
         </p:nvSpPr>
         <p:spPr>
           <a:xfrm>
-            <a:off x="9905695" y="457200"/>
+            <a:off x="9905695" y="438912"/>
             <a:ext cx="1417320" cy="292608"/>
           </a:xfrm>
           <a:prstGeom prst="rect">
@@ -3019,11 +2924,11 @@
             </a:avLst>
           </a:prstGeom>
           <a:solidFill>
-            <a:srgbClr val="F0F4F5"/>
+            <a:srgbClr val="F6F2EC"/>
           </a:solidFill>
           <a:ln w="6350">
             <a:solidFill>
-              <a:srgbClr val="F0F4F5"/>
+              <a:srgbClr val="F6F2EC"/>
             </a:solidFill>
             <a:prstDash val="solid"/>
           </a:ln>
@@ -3051,11 +2956,11 @@
             <a:avLst/>
           </a:prstGeom>
           <a:solidFill>
-            <a:srgbClr val="1E8077"/>
+            <a:srgbClr val="C8652A"/>
           </a:solidFill>
           <a:ln w="6350">
             <a:solidFill>
-              <a:srgbClr val="1E8077"/>
+              <a:srgbClr val="C8652A"/>
             </a:solidFill>
             <a:prstDash val="solid"/>
           </a:ln>
@@ -3127,7 +3032,7 @@
             <a:r>
               <a:rPr lang="en-US" sz="1800" b="1" dirty="0">
                 <a:solidFill>
-                  <a:srgbClr val="15202B"/>
+                  <a:srgbClr val="1C2620"/>
                 </a:solidFill>
                 <a:latin typeface="Arial" pitchFamily="34" charset="0"/>
                 <a:ea typeface="Arial" pitchFamily="34" charset="-122"/>
@@ -3169,7 +3074,7 @@
             <a:r>
               <a:rPr lang="en-US" sz="1300" dirty="0">
                 <a:solidFill>
-                  <a:srgbClr val="5B6670"/>
+                  <a:srgbClr val="5F665F"/>
                 </a:solidFill>
                 <a:latin typeface="Calibri" pitchFamily="34" charset="0"/>
                 <a:ea typeface="Calibri" pitchFamily="34" charset="-122"/>
@@ -3198,11 +3103,11 @@
             </a:avLst>
           </a:prstGeom>
           <a:solidFill>
-            <a:srgbClr val="F0F4F5"/>
+            <a:srgbClr val="F6F2EC"/>
           </a:solidFill>
           <a:ln w="6350">
             <a:solidFill>
-              <a:srgbClr val="F0F4F5"/>
+              <a:srgbClr val="F6F2EC"/>
             </a:solidFill>
             <a:prstDash val="solid"/>
           </a:ln>
@@ -3230,11 +3135,11 @@
             <a:avLst/>
           </a:prstGeom>
           <a:solidFill>
-            <a:srgbClr val="1E8077"/>
+            <a:srgbClr val="C8652A"/>
           </a:solidFill>
           <a:ln w="6350">
             <a:solidFill>
-              <a:srgbClr val="1E8077"/>
+              <a:srgbClr val="C8652A"/>
             </a:solidFill>
             <a:prstDash val="solid"/>
           </a:ln>
@@ -3306,7 +3211,7 @@
             <a:r>
               <a:rPr lang="en-US" sz="1800" b="1" dirty="0">
                 <a:solidFill>
-                  <a:srgbClr val="15202B"/>
+                  <a:srgbClr val="1C2620"/>
                 </a:solidFill>
                 <a:latin typeface="Arial" pitchFamily="34" charset="0"/>
                 <a:ea typeface="Arial" pitchFamily="34" charset="-122"/>
@@ -3348,7 +3253,7 @@
             <a:r>
               <a:rPr lang="en-US" sz="1300" dirty="0">
                 <a:solidFill>
-                  <a:srgbClr val="5B6670"/>
+                  <a:srgbClr val="5F665F"/>
                 </a:solidFill>
                 <a:latin typeface="Calibri" pitchFamily="34" charset="0"/>
                 <a:ea typeface="Calibri" pitchFamily="34" charset="-122"/>
@@ -3377,11 +3282,11 @@
             </a:avLst>
           </a:prstGeom>
           <a:solidFill>
-            <a:srgbClr val="15202B"/>
+            <a:srgbClr val="1C2620"/>
           </a:solidFill>
           <a:ln w="6350">
             <a:solidFill>
-              <a:srgbClr val="15202B"/>
+              <a:srgbClr val="1C2620"/>
             </a:solidFill>
             <a:prstDash val="solid"/>
           </a:ln>
@@ -3409,11 +3314,11 @@
             <a:avLst/>
           </a:prstGeom>
           <a:solidFill>
-            <a:srgbClr val="1E8077"/>
+            <a:srgbClr val="C8652A"/>
           </a:solidFill>
           <a:ln w="6350">
             <a:solidFill>
-              <a:srgbClr val="1E8077"/>
+              <a:srgbClr val="C8652A"/>
             </a:solidFill>
             <a:prstDash val="solid"/>
           </a:ln>
@@ -3527,7 +3432,7 @@
             <a:r>
               <a:rPr lang="en-US" sz="1300" dirty="0">
                 <a:solidFill>
-                  <a:srgbClr val="A7B4BF"/>
+                  <a:srgbClr val="AEB8AF"/>
                 </a:solidFill>
                 <a:latin typeface="Calibri" pitchFamily="34" charset="0"/>
                 <a:ea typeface="Calibri" pitchFamily="34" charset="-122"/>
@@ -3566,13 +3471,13 @@
             <a:r>
               <a:rPr lang="en-US" sz="1000" dirty="0">
                 <a:solidFill>
-                  <a:srgbClr val="5B6670"/>
+                  <a:srgbClr val="5F665F"/>
                 </a:solidFill>
                 <a:latin typeface="Calibri" pitchFamily="34" charset="0"/>
                 <a:ea typeface="Calibri" pitchFamily="34" charset="-122"/>
                 <a:cs typeface="Calibri" pitchFamily="34" charset="-120"/>
               </a:rPr>
-              <a:t>Prepared by Sean</a:t>
+              <a:t>Sean</a:t>
             </a:r>
             <a:endParaRPr lang="en-US" sz="1000" dirty="0"/>
           </a:p>
@@ -3605,7 +3510,7 @@
             <a:r>
               <a:rPr lang="en-US" sz="1000" dirty="0">
                 <a:solidFill>
-                  <a:srgbClr val="5B6670"/>
+                  <a:srgbClr val="5F665F"/>
                 </a:solidFill>
                 <a:latin typeface="Calibri" pitchFamily="34" charset="0"/>
                 <a:ea typeface="Calibri" pitchFamily="34" charset="-122"/>
@@ -3676,13 +3581,13 @@
             <a:r>
               <a:rPr lang="en-US" sz="1200" b="1" spc="200" kern="0" dirty="0">
                 <a:solidFill>
-                  <a:srgbClr val="1E8077"/>
+                  <a:srgbClr val="C8652A"/>
                 </a:solidFill>
                 <a:latin typeface="Calibri" pitchFamily="34" charset="0"/>
                 <a:ea typeface="Calibri" pitchFamily="34" charset="-122"/>
                 <a:cs typeface="Calibri" pitchFamily="34" charset="-120"/>
               </a:rPr>
-              <a:t>02   PRODUCT SUGGESTIONS</a:t>
+              <a:t>04   PRODUCT SUGGESTIONS</a:t>
             </a:r>
             <a:endParaRPr lang="en-US" sz="1200" dirty="0"/>
           </a:p>
@@ -3697,7 +3602,7 @@
         <p:spPr>
           <a:xfrm>
             <a:off x="685800" y="768096"/>
-            <a:ext cx="10820095" cy="640080"/>
+            <a:ext cx="10820095" cy="914400"/>
           </a:xfrm>
           <a:prstGeom prst="rect">
             <a:avLst/>
@@ -3715,7 +3620,7 @@
             <a:r>
               <a:rPr lang="en-US" sz="3200" b="1" dirty="0">
                 <a:solidFill>
-                  <a:srgbClr val="15202B"/>
+                  <a:srgbClr val="1C2620"/>
                 </a:solidFill>
                 <a:latin typeface="Arial" pitchFamily="34" charset="0"/>
                 <a:ea typeface="Arial" pitchFamily="34" charset="-122"/>
@@ -3744,11 +3649,11 @@
             </a:avLst>
           </a:prstGeom>
           <a:solidFill>
-            <a:srgbClr val="F0F4F5"/>
+            <a:srgbClr val="F6F2EC"/>
           </a:solidFill>
           <a:ln w="6350">
             <a:solidFill>
-              <a:srgbClr val="F0F4F5"/>
+              <a:srgbClr val="F6F2EC"/>
             </a:solidFill>
             <a:prstDash val="solid"/>
           </a:ln>
@@ -3788,7 +3693,7 @@
             <a:r>
               <a:rPr lang="en-US" sz="1100" b="1" spc="200" kern="0" dirty="0">
                 <a:solidFill>
-                  <a:srgbClr val="1E8077"/>
+                  <a:srgbClr val="C8652A"/>
                 </a:solidFill>
                 <a:latin typeface="Calibri" pitchFamily="34" charset="0"/>
                 <a:ea typeface="Calibri" pitchFamily="34" charset="-122"/>
@@ -3827,7 +3732,7 @@
             <a:r>
               <a:rPr lang="en-US" sz="1800" b="1" dirty="0">
                 <a:solidFill>
-                  <a:srgbClr val="15202B"/>
+                  <a:srgbClr val="1C2620"/>
                 </a:solidFill>
                 <a:latin typeface="Arial" pitchFamily="34" charset="0"/>
                 <a:ea typeface="Arial" pitchFamily="34" charset="-122"/>
@@ -3866,7 +3771,7 @@
             <a:r>
               <a:rPr lang="en-US" sz="1300" b="1" dirty="0">
                 <a:solidFill>
-                  <a:srgbClr val="15202B"/>
+                  <a:srgbClr val="1C2620"/>
                 </a:solidFill>
                 <a:latin typeface="Calibri" pitchFamily="34" charset="0"/>
                 <a:ea typeface="Calibri" pitchFamily="34" charset="-122"/>
@@ -3908,7 +3813,7 @@
             <a:r>
               <a:rPr lang="en-US" sz="1300" dirty="0">
                 <a:solidFill>
-                  <a:srgbClr val="5B6670"/>
+                  <a:srgbClr val="5F665F"/>
                 </a:solidFill>
                 <a:latin typeface="Calibri" pitchFamily="34" charset="0"/>
                 <a:ea typeface="Calibri" pitchFamily="34" charset="-122"/>
@@ -3937,7 +3842,7 @@
           <a:noFill/>
           <a:ln w="9525">
             <a:solidFill>
-              <a:srgbClr val="5B6670">
+              <a:srgbClr val="5F665F">
                 <a:alpha val="35000"/>
               </a:srgbClr>
             </a:solidFill>
@@ -3972,7 +3877,7 @@
             <a:r>
               <a:rPr lang="en-US" sz="1300" b="1" dirty="0">
                 <a:solidFill>
-                  <a:srgbClr val="1E8077"/>
+                  <a:srgbClr val="C8652A"/>
                 </a:solidFill>
                 <a:latin typeface="Calibri" pitchFamily="34" charset="0"/>
                 <a:ea typeface="Calibri" pitchFamily="34" charset="-122"/>
@@ -4014,7 +3919,7 @@
             <a:r>
               <a:rPr lang="en-US" sz="1300" dirty="0">
                 <a:solidFill>
-                  <a:srgbClr val="5B6670"/>
+                  <a:srgbClr val="5F665F"/>
                 </a:solidFill>
                 <a:latin typeface="Calibri" pitchFamily="34" charset="0"/>
                 <a:ea typeface="Calibri" pitchFamily="34" charset="-122"/>
@@ -4043,11 +3948,11 @@
             </a:avLst>
           </a:prstGeom>
           <a:solidFill>
-            <a:srgbClr val="F0F4F5"/>
+            <a:srgbClr val="F6F2EC"/>
           </a:solidFill>
           <a:ln w="6350">
             <a:solidFill>
-              <a:srgbClr val="F0F4F5"/>
+              <a:srgbClr val="F6F2EC"/>
             </a:solidFill>
             <a:prstDash val="solid"/>
           </a:ln>
@@ -4087,7 +3992,7 @@
             <a:r>
               <a:rPr lang="en-US" sz="1100" b="1" spc="200" kern="0" dirty="0">
                 <a:solidFill>
-                  <a:srgbClr val="1E8077"/>
+                  <a:srgbClr val="C8652A"/>
                 </a:solidFill>
                 <a:latin typeface="Calibri" pitchFamily="34" charset="0"/>
                 <a:ea typeface="Calibri" pitchFamily="34" charset="-122"/>
@@ -4126,7 +4031,7 @@
             <a:r>
               <a:rPr lang="en-US" sz="1800" b="1" dirty="0">
                 <a:solidFill>
-                  <a:srgbClr val="15202B"/>
+                  <a:srgbClr val="1C2620"/>
                 </a:solidFill>
                 <a:latin typeface="Arial" pitchFamily="34" charset="0"/>
                 <a:ea typeface="Arial" pitchFamily="34" charset="-122"/>
@@ -4165,7 +4070,7 @@
             <a:r>
               <a:rPr lang="en-US" sz="1300" b="1" dirty="0">
                 <a:solidFill>
-                  <a:srgbClr val="15202B"/>
+                  <a:srgbClr val="1C2620"/>
                 </a:solidFill>
                 <a:latin typeface="Calibri" pitchFamily="34" charset="0"/>
                 <a:ea typeface="Calibri" pitchFamily="34" charset="-122"/>
@@ -4207,7 +4112,7 @@
             <a:r>
               <a:rPr lang="en-US" sz="1300" dirty="0">
                 <a:solidFill>
-                  <a:srgbClr val="5B6670"/>
+                  <a:srgbClr val="5F665F"/>
                 </a:solidFill>
                 <a:latin typeface="Calibri" pitchFamily="34" charset="0"/>
                 <a:ea typeface="Calibri" pitchFamily="34" charset="-122"/>
@@ -4236,7 +4141,7 @@
           <a:noFill/>
           <a:ln w="9525">
             <a:solidFill>
-              <a:srgbClr val="5B6670">
+              <a:srgbClr val="5F665F">
                 <a:alpha val="35000"/>
               </a:srgbClr>
             </a:solidFill>
@@ -4271,7 +4176,7 @@
             <a:r>
               <a:rPr lang="en-US" sz="1300" b="1" dirty="0">
                 <a:solidFill>
-                  <a:srgbClr val="1E8077"/>
+                  <a:srgbClr val="C8652A"/>
                 </a:solidFill>
                 <a:latin typeface="Calibri" pitchFamily="34" charset="0"/>
                 <a:ea typeface="Calibri" pitchFamily="34" charset="-122"/>
@@ -4313,7 +4218,7 @@
             <a:r>
               <a:rPr lang="en-US" sz="1300" dirty="0">
                 <a:solidFill>
-                  <a:srgbClr val="5B6670"/>
+                  <a:srgbClr val="5F665F"/>
                 </a:solidFill>
                 <a:latin typeface="Calibri" pitchFamily="34" charset="0"/>
                 <a:ea typeface="Calibri" pitchFamily="34" charset="-122"/>
@@ -4352,13 +4257,13 @@
             <a:r>
               <a:rPr lang="en-US" sz="1000" dirty="0">
                 <a:solidFill>
-                  <a:srgbClr val="5B6670"/>
+                  <a:srgbClr val="5F665F"/>
                 </a:solidFill>
                 <a:latin typeface="Calibri" pitchFamily="34" charset="0"/>
                 <a:ea typeface="Calibri" pitchFamily="34" charset="-122"/>
                 <a:cs typeface="Calibri" pitchFamily="34" charset="-120"/>
               </a:rPr>
-              <a:t>Prepared by Sean</a:t>
+              <a:t>Sean</a:t>
             </a:r>
             <a:endParaRPr lang="en-US" sz="1000" dirty="0"/>
           </a:p>
@@ -4391,7 +4296,7 @@
             <a:r>
               <a:rPr lang="en-US" sz="1000" dirty="0">
                 <a:solidFill>
-                  <a:srgbClr val="5B6670"/>
+                  <a:srgbClr val="5F665F"/>
                 </a:solidFill>
                 <a:latin typeface="Calibri" pitchFamily="34" charset="0"/>
                 <a:ea typeface="Calibri" pitchFamily="34" charset="-122"/>
@@ -4462,13 +4367,13 @@
             <a:r>
               <a:rPr lang="en-US" sz="1200" b="1" spc="200" kern="0" dirty="0">
                 <a:solidFill>
-                  <a:srgbClr val="1E8077"/>
+                  <a:srgbClr val="C8652A"/>
                 </a:solidFill>
                 <a:latin typeface="Calibri" pitchFamily="34" charset="0"/>
                 <a:ea typeface="Calibri" pitchFamily="34" charset="-122"/>
                 <a:cs typeface="Calibri" pitchFamily="34" charset="-120"/>
               </a:rPr>
-              <a:t>03   IMPLEMENTATION PLAN</a:t>
+              <a:t>05   IMPLEMENTATION PLAN</a:t>
             </a:r>
             <a:endParaRPr lang="en-US" sz="1200" dirty="0"/>
           </a:p>
@@ -4483,7 +4388,7 @@
         <p:spPr>
           <a:xfrm>
             <a:off x="685800" y="768096"/>
-            <a:ext cx="10820095" cy="640080"/>
+            <a:ext cx="10820095" cy="914400"/>
           </a:xfrm>
           <a:prstGeom prst="rect">
             <a:avLst/>
@@ -4501,7 +4406,7 @@
             <a:r>
               <a:rPr lang="en-US" sz="2400" b="1" dirty="0">
                 <a:solidFill>
-                  <a:srgbClr val="15202B"/>
+                  <a:srgbClr val="1C2620"/>
                 </a:solidFill>
                 <a:latin typeface="Arial" pitchFamily="34" charset="0"/>
                 <a:ea typeface="Arial" pitchFamily="34" charset="-122"/>
@@ -4521,7 +4426,7 @@
         </p:nvSpPr>
         <p:spPr>
           <a:xfrm>
-            <a:off x="896112" y="1837944"/>
+            <a:off x="896112" y="1965960"/>
             <a:ext cx="0" cy="3657600"/>
           </a:xfrm>
           <a:prstGeom prst="line">
@@ -4530,7 +4435,7 @@
           <a:noFill/>
           <a:ln w="19050">
             <a:solidFill>
-              <a:srgbClr val="1E8077">
+              <a:srgbClr val="C8652A">
                 <a:alpha val="50000"/>
               </a:srgbClr>
             </a:solidFill>
@@ -4546,18 +4451,18 @@
         </p:nvSpPr>
         <p:spPr>
           <a:xfrm>
-            <a:off x="685800" y="1627632"/>
+            <a:off x="685800" y="1719072"/>
             <a:ext cx="420624" cy="420624"/>
           </a:xfrm>
           <a:prstGeom prst="ellipse">
             <a:avLst/>
           </a:prstGeom>
           <a:solidFill>
-            <a:srgbClr val="1E8077"/>
+            <a:srgbClr val="C8652A"/>
           </a:solidFill>
           <a:ln w="6350">
             <a:solidFill>
-              <a:srgbClr val="1E8077"/>
+              <a:srgbClr val="C8652A"/>
             </a:solidFill>
             <a:prstDash val="solid"/>
           </a:ln>
@@ -4571,7 +4476,7 @@
         </p:nvSpPr>
         <p:spPr>
           <a:xfrm>
-            <a:off x="685800" y="1627632"/>
+            <a:off x="685800" y="1719072"/>
             <a:ext cx="420624" cy="420624"/>
           </a:xfrm>
           <a:prstGeom prst="rect">
@@ -4610,7 +4515,7 @@
         </p:nvSpPr>
         <p:spPr>
           <a:xfrm>
-            <a:off x="1325880" y="1527048"/>
+            <a:off x="1325880" y="1618488"/>
             <a:ext cx="10180015" cy="640080"/>
           </a:xfrm>
           <a:prstGeom prst="roundRect">
@@ -4619,11 +4524,11 @@
             </a:avLst>
           </a:prstGeom>
           <a:solidFill>
-            <a:srgbClr val="F0F4F5"/>
+            <a:srgbClr val="F6F2EC"/>
           </a:solidFill>
           <a:ln w="6350">
             <a:solidFill>
-              <a:srgbClr val="F0F4F5"/>
+              <a:srgbClr val="F6F2EC"/>
             </a:solidFill>
             <a:prstDash val="solid"/>
           </a:ln>
@@ -4644,7 +4549,7 @@
         </p:nvSpPr>
         <p:spPr>
           <a:xfrm>
-            <a:off x="1600200" y="1527048"/>
+            <a:off x="1600200" y="1618488"/>
             <a:ext cx="1828800" cy="640080"/>
           </a:xfrm>
           <a:prstGeom prst="rect">
@@ -4663,7 +4568,7 @@
             <a:r>
               <a:rPr lang="en-US" sz="950" b="1" spc="150" kern="0" dirty="0">
                 <a:solidFill>
-                  <a:srgbClr val="1E8077"/>
+                  <a:srgbClr val="C8652A"/>
                 </a:solidFill>
                 <a:latin typeface="Calibri" pitchFamily="34" charset="0"/>
                 <a:ea typeface="Calibri" pitchFamily="34" charset="-122"/>
@@ -4680,7 +4585,7 @@
             <a:r>
               <a:rPr lang="en-US" sz="1500" b="1" dirty="0">
                 <a:solidFill>
-                  <a:srgbClr val="15202B"/>
+                  <a:srgbClr val="1C2620"/>
                 </a:solidFill>
                 <a:latin typeface="Arial" pitchFamily="34" charset="0"/>
                 <a:ea typeface="Arial" pitchFamily="34" charset="-122"/>
@@ -4700,7 +4605,7 @@
         </p:nvSpPr>
         <p:spPr>
           <a:xfrm>
-            <a:off x="3520440" y="1527048"/>
+            <a:off x="3520440" y="1618488"/>
             <a:ext cx="7711135" cy="640080"/>
           </a:xfrm>
           <a:prstGeom prst="rect">
@@ -4722,7 +4627,7 @@
             <a:r>
               <a:rPr lang="en-US" sz="1150" dirty="0">
                 <a:solidFill>
-                  <a:srgbClr val="5B6670"/>
+                  <a:srgbClr val="5F665F"/>
                 </a:solidFill>
                 <a:latin typeface="Calibri" pitchFamily="34" charset="0"/>
                 <a:ea typeface="Calibri" pitchFamily="34" charset="-122"/>
@@ -4742,18 +4647,18 @@
         </p:nvSpPr>
         <p:spPr>
           <a:xfrm>
-            <a:off x="685800" y="2359152"/>
+            <a:off x="685800" y="2450592"/>
             <a:ext cx="420624" cy="420624"/>
           </a:xfrm>
           <a:prstGeom prst="ellipse">
             <a:avLst/>
           </a:prstGeom>
           <a:solidFill>
-            <a:srgbClr val="1E8077"/>
+            <a:srgbClr val="C8652A"/>
           </a:solidFill>
           <a:ln w="6350">
             <a:solidFill>
-              <a:srgbClr val="1E8077"/>
+              <a:srgbClr val="C8652A"/>
             </a:solidFill>
             <a:prstDash val="solid"/>
           </a:ln>
@@ -4767,7 +4672,7 @@
         </p:nvSpPr>
         <p:spPr>
           <a:xfrm>
-            <a:off x="685800" y="2359152"/>
+            <a:off x="685800" y="2450592"/>
             <a:ext cx="420624" cy="420624"/>
           </a:xfrm>
           <a:prstGeom prst="rect">
@@ -4806,7 +4711,7 @@
         </p:nvSpPr>
         <p:spPr>
           <a:xfrm>
-            <a:off x="1325880" y="2258568"/>
+            <a:off x="1325880" y="2350008"/>
             <a:ext cx="10180015" cy="640080"/>
           </a:xfrm>
           <a:prstGeom prst="roundRect">
@@ -4815,11 +4720,11 @@
             </a:avLst>
           </a:prstGeom>
           <a:solidFill>
-            <a:srgbClr val="F0F4F5"/>
+            <a:srgbClr val="F6F2EC"/>
           </a:solidFill>
           <a:ln w="6350">
             <a:solidFill>
-              <a:srgbClr val="F0F4F5"/>
+              <a:srgbClr val="F6F2EC"/>
             </a:solidFill>
             <a:prstDash val="solid"/>
           </a:ln>
@@ -4840,7 +4745,7 @@
         </p:nvSpPr>
         <p:spPr>
           <a:xfrm>
-            <a:off x="1600200" y="2258568"/>
+            <a:off x="1600200" y="2350008"/>
             <a:ext cx="1828800" cy="640080"/>
           </a:xfrm>
           <a:prstGeom prst="rect">
@@ -4859,7 +4764,7 @@
             <a:r>
               <a:rPr lang="en-US" sz="950" b="1" spc="150" kern="0" dirty="0">
                 <a:solidFill>
-                  <a:srgbClr val="1E8077"/>
+                  <a:srgbClr val="C8652A"/>
                 </a:solidFill>
                 <a:latin typeface="Calibri" pitchFamily="34" charset="0"/>
                 <a:ea typeface="Calibri" pitchFamily="34" charset="-122"/>
@@ -4876,7 +4781,7 @@
             <a:r>
               <a:rPr lang="en-US" sz="1500" b="1" dirty="0">
                 <a:solidFill>
-                  <a:srgbClr val="15202B"/>
+                  <a:srgbClr val="1C2620"/>
                 </a:solidFill>
                 <a:latin typeface="Arial" pitchFamily="34" charset="0"/>
                 <a:ea typeface="Arial" pitchFamily="34" charset="-122"/>
@@ -4896,7 +4801,7 @@
         </p:nvSpPr>
         <p:spPr>
           <a:xfrm>
-            <a:off x="3520440" y="2258568"/>
+            <a:off x="3520440" y="2350008"/>
             <a:ext cx="7711135" cy="640080"/>
           </a:xfrm>
           <a:prstGeom prst="rect">
@@ -4918,7 +4823,7 @@
             <a:r>
               <a:rPr lang="en-US" sz="1150" dirty="0">
                 <a:solidFill>
-                  <a:srgbClr val="5B6670"/>
+                  <a:srgbClr val="5F665F"/>
                 </a:solidFill>
                 <a:latin typeface="Calibri" pitchFamily="34" charset="0"/>
                 <a:ea typeface="Calibri" pitchFamily="34" charset="-122"/>
@@ -4938,18 +4843,18 @@
         </p:nvSpPr>
         <p:spPr>
           <a:xfrm>
-            <a:off x="685800" y="3090672"/>
+            <a:off x="685800" y="3182112"/>
             <a:ext cx="420624" cy="420624"/>
           </a:xfrm>
           <a:prstGeom prst="ellipse">
             <a:avLst/>
           </a:prstGeom>
           <a:solidFill>
-            <a:srgbClr val="1E8077"/>
+            <a:srgbClr val="C8652A"/>
           </a:solidFill>
           <a:ln w="6350">
             <a:solidFill>
-              <a:srgbClr val="1E8077"/>
+              <a:srgbClr val="C8652A"/>
             </a:solidFill>
             <a:prstDash val="solid"/>
           </a:ln>
@@ -4963,7 +4868,7 @@
         </p:nvSpPr>
         <p:spPr>
           <a:xfrm>
-            <a:off x="685800" y="3090672"/>
+            <a:off x="685800" y="3182112"/>
             <a:ext cx="420624" cy="420624"/>
           </a:xfrm>
           <a:prstGeom prst="rect">
@@ -5002,7 +4907,7 @@
         </p:nvSpPr>
         <p:spPr>
           <a:xfrm>
-            <a:off x="1325880" y="2990088"/>
+            <a:off x="1325880" y="3081528"/>
             <a:ext cx="10180015" cy="640080"/>
           </a:xfrm>
           <a:prstGeom prst="roundRect">
@@ -5011,11 +4916,11 @@
             </a:avLst>
           </a:prstGeom>
           <a:solidFill>
-            <a:srgbClr val="F0F4F5"/>
+            <a:srgbClr val="F6F2EC"/>
           </a:solidFill>
           <a:ln w="6350">
             <a:solidFill>
-              <a:srgbClr val="F0F4F5"/>
+              <a:srgbClr val="F6F2EC"/>
             </a:solidFill>
             <a:prstDash val="solid"/>
           </a:ln>
@@ -5036,7 +4941,7 @@
         </p:nvSpPr>
         <p:spPr>
           <a:xfrm>
-            <a:off x="1600200" y="2990088"/>
+            <a:off x="1600200" y="3081528"/>
             <a:ext cx="1828800" cy="640080"/>
           </a:xfrm>
           <a:prstGeom prst="rect">
@@ -5055,7 +4960,7 @@
             <a:r>
               <a:rPr lang="en-US" sz="950" b="1" spc="150" kern="0" dirty="0">
                 <a:solidFill>
-                  <a:srgbClr val="1E8077"/>
+                  <a:srgbClr val="C8652A"/>
                 </a:solidFill>
                 <a:latin typeface="Calibri" pitchFamily="34" charset="0"/>
                 <a:ea typeface="Calibri" pitchFamily="34" charset="-122"/>
@@ -5072,7 +4977,7 @@
             <a:r>
               <a:rPr lang="en-US" sz="1500" b="1" dirty="0">
                 <a:solidFill>
-                  <a:srgbClr val="15202B"/>
+                  <a:srgbClr val="1C2620"/>
                 </a:solidFill>
                 <a:latin typeface="Arial" pitchFamily="34" charset="0"/>
                 <a:ea typeface="Arial" pitchFamily="34" charset="-122"/>
@@ -5092,7 +4997,7 @@
         </p:nvSpPr>
         <p:spPr>
           <a:xfrm>
-            <a:off x="3520440" y="2990088"/>
+            <a:off x="3520440" y="3081528"/>
             <a:ext cx="7711135" cy="640080"/>
           </a:xfrm>
           <a:prstGeom prst="rect">
@@ -5114,7 +5019,7 @@
             <a:r>
               <a:rPr lang="en-US" sz="1150" dirty="0">
                 <a:solidFill>
-                  <a:srgbClr val="5B6670"/>
+                  <a:srgbClr val="5F665F"/>
                 </a:solidFill>
                 <a:latin typeface="Calibri" pitchFamily="34" charset="0"/>
                 <a:ea typeface="Calibri" pitchFamily="34" charset="-122"/>
@@ -5134,18 +5039,18 @@
         </p:nvSpPr>
         <p:spPr>
           <a:xfrm>
-            <a:off x="685800" y="3822192"/>
+            <a:off x="685800" y="3913632"/>
             <a:ext cx="420624" cy="420624"/>
           </a:xfrm>
           <a:prstGeom prst="ellipse">
             <a:avLst/>
           </a:prstGeom>
           <a:solidFill>
-            <a:srgbClr val="1E8077"/>
+            <a:srgbClr val="C8652A"/>
           </a:solidFill>
           <a:ln w="6350">
             <a:solidFill>
-              <a:srgbClr val="1E8077"/>
+              <a:srgbClr val="C8652A"/>
             </a:solidFill>
             <a:prstDash val="solid"/>
           </a:ln>
@@ -5159,7 +5064,7 @@
         </p:nvSpPr>
         <p:spPr>
           <a:xfrm>
-            <a:off x="685800" y="3822192"/>
+            <a:off x="685800" y="3913632"/>
             <a:ext cx="420624" cy="420624"/>
           </a:xfrm>
           <a:prstGeom prst="rect">
@@ -5198,7 +5103,7 @@
         </p:nvSpPr>
         <p:spPr>
           <a:xfrm>
-            <a:off x="1325880" y="3721608"/>
+            <a:off x="1325880" y="3813048"/>
             <a:ext cx="10180015" cy="640080"/>
           </a:xfrm>
           <a:prstGeom prst="roundRect">
@@ -5207,11 +5112,11 @@
             </a:avLst>
           </a:prstGeom>
           <a:solidFill>
-            <a:srgbClr val="F0F4F5"/>
+            <a:srgbClr val="F6F2EC"/>
           </a:solidFill>
           <a:ln w="6350">
             <a:solidFill>
-              <a:srgbClr val="F0F4F5"/>
+              <a:srgbClr val="F6F2EC"/>
             </a:solidFill>
             <a:prstDash val="solid"/>
           </a:ln>
@@ -5232,7 +5137,7 @@
         </p:nvSpPr>
         <p:spPr>
           <a:xfrm>
-            <a:off x="1600200" y="3721608"/>
+            <a:off x="1600200" y="3813048"/>
             <a:ext cx="1828800" cy="640080"/>
           </a:xfrm>
           <a:prstGeom prst="rect">
@@ -5251,7 +5156,7 @@
             <a:r>
               <a:rPr lang="en-US" sz="950" b="1" spc="150" kern="0" dirty="0">
                 <a:solidFill>
-                  <a:srgbClr val="1E8077"/>
+                  <a:srgbClr val="C8652A"/>
                 </a:solidFill>
                 <a:latin typeface="Calibri" pitchFamily="34" charset="0"/>
                 <a:ea typeface="Calibri" pitchFamily="34" charset="-122"/>
@@ -5268,7 +5173,7 @@
             <a:r>
               <a:rPr lang="en-US" sz="1500" b="1" dirty="0">
                 <a:solidFill>
-                  <a:srgbClr val="15202B"/>
+                  <a:srgbClr val="1C2620"/>
                 </a:solidFill>
                 <a:latin typeface="Arial" pitchFamily="34" charset="0"/>
                 <a:ea typeface="Arial" pitchFamily="34" charset="-122"/>
@@ -5288,7 +5193,7 @@
         </p:nvSpPr>
         <p:spPr>
           <a:xfrm>
-            <a:off x="3520440" y="3721608"/>
+            <a:off x="3520440" y="3813048"/>
             <a:ext cx="7711135" cy="640080"/>
           </a:xfrm>
           <a:prstGeom prst="rect">
@@ -5310,7 +5215,7 @@
             <a:r>
               <a:rPr lang="en-US" sz="1150" dirty="0">
                 <a:solidFill>
-                  <a:srgbClr val="5B6670"/>
+                  <a:srgbClr val="5F665F"/>
                 </a:solidFill>
                 <a:latin typeface="Calibri" pitchFamily="34" charset="0"/>
                 <a:ea typeface="Calibri" pitchFamily="34" charset="-122"/>
@@ -5330,18 +5235,18 @@
         </p:nvSpPr>
         <p:spPr>
           <a:xfrm>
-            <a:off x="685800" y="4553712"/>
+            <a:off x="685800" y="4645152"/>
             <a:ext cx="420624" cy="420624"/>
           </a:xfrm>
           <a:prstGeom prst="ellipse">
             <a:avLst/>
           </a:prstGeom>
           <a:solidFill>
-            <a:srgbClr val="1E8077"/>
+            <a:srgbClr val="C8652A"/>
           </a:solidFill>
           <a:ln w="6350">
             <a:solidFill>
-              <a:srgbClr val="1E8077"/>
+              <a:srgbClr val="C8652A"/>
             </a:solidFill>
             <a:prstDash val="solid"/>
           </a:ln>
@@ -5355,7 +5260,7 @@
         </p:nvSpPr>
         <p:spPr>
           <a:xfrm>
-            <a:off x="685800" y="4553712"/>
+            <a:off x="685800" y="4645152"/>
             <a:ext cx="420624" cy="420624"/>
           </a:xfrm>
           <a:prstGeom prst="rect">
@@ -5394,7 +5299,7 @@
         </p:nvSpPr>
         <p:spPr>
           <a:xfrm>
-            <a:off x="1325880" y="4453128"/>
+            <a:off x="1325880" y="4544568"/>
             <a:ext cx="10180015" cy="640080"/>
           </a:xfrm>
           <a:prstGeom prst="roundRect">
@@ -5403,11 +5308,11 @@
             </a:avLst>
           </a:prstGeom>
           <a:solidFill>
-            <a:srgbClr val="DCEDEB"/>
+            <a:srgbClr val="F3E3D6"/>
           </a:solidFill>
           <a:ln w="6350">
             <a:solidFill>
-              <a:srgbClr val="DCEDEB"/>
+              <a:srgbClr val="F3E3D6"/>
             </a:solidFill>
             <a:prstDash val="solid"/>
           </a:ln>
@@ -5428,7 +5333,7 @@
         </p:nvSpPr>
         <p:spPr>
           <a:xfrm>
-            <a:off x="1600200" y="4453128"/>
+            <a:off x="1600200" y="4544568"/>
             <a:ext cx="1828800" cy="640080"/>
           </a:xfrm>
           <a:prstGeom prst="rect">
@@ -5447,7 +5352,7 @@
             <a:r>
               <a:rPr lang="en-US" sz="950" b="1" spc="150" kern="0" dirty="0">
                 <a:solidFill>
-                  <a:srgbClr val="1E8077"/>
+                  <a:srgbClr val="C8652A"/>
                 </a:solidFill>
                 <a:latin typeface="Calibri" pitchFamily="34" charset="0"/>
                 <a:ea typeface="Calibri" pitchFamily="34" charset="-122"/>
@@ -5464,7 +5369,7 @@
             <a:r>
               <a:rPr lang="en-US" sz="1500" b="1" dirty="0">
                 <a:solidFill>
-                  <a:srgbClr val="15202B"/>
+                  <a:srgbClr val="1C2620"/>
                 </a:solidFill>
                 <a:latin typeface="Arial" pitchFamily="34" charset="0"/>
                 <a:ea typeface="Arial" pitchFamily="34" charset="-122"/>
@@ -5484,7 +5389,7 @@
         </p:nvSpPr>
         <p:spPr>
           <a:xfrm>
-            <a:off x="3520440" y="4453128"/>
+            <a:off x="3520440" y="4544568"/>
             <a:ext cx="7711135" cy="640080"/>
           </a:xfrm>
           <a:prstGeom prst="rect">
@@ -5506,7 +5411,7 @@
             <a:r>
               <a:rPr lang="en-US" sz="1150" dirty="0">
                 <a:solidFill>
-                  <a:srgbClr val="5B6670"/>
+                  <a:srgbClr val="5F665F"/>
                 </a:solidFill>
                 <a:latin typeface="Calibri" pitchFamily="34" charset="0"/>
                 <a:ea typeface="Calibri" pitchFamily="34" charset="-122"/>
@@ -5526,18 +5431,18 @@
         </p:nvSpPr>
         <p:spPr>
           <a:xfrm>
-            <a:off x="685800" y="5285232"/>
+            <a:off x="685800" y="5376672"/>
             <a:ext cx="420624" cy="420624"/>
           </a:xfrm>
           <a:prstGeom prst="ellipse">
             <a:avLst/>
           </a:prstGeom>
           <a:solidFill>
-            <a:srgbClr val="1E8077"/>
+            <a:srgbClr val="C8652A"/>
           </a:solidFill>
           <a:ln w="6350">
             <a:solidFill>
-              <a:srgbClr val="1E8077"/>
+              <a:srgbClr val="C8652A"/>
             </a:solidFill>
             <a:prstDash val="solid"/>
           </a:ln>
@@ -5551,7 +5456,7 @@
         </p:nvSpPr>
         <p:spPr>
           <a:xfrm>
-            <a:off x="685800" y="5285232"/>
+            <a:off x="685800" y="5376672"/>
             <a:ext cx="420624" cy="420624"/>
           </a:xfrm>
           <a:prstGeom prst="rect">
@@ -5590,7 +5495,7 @@
         </p:nvSpPr>
         <p:spPr>
           <a:xfrm>
-            <a:off x="1325880" y="5184648"/>
+            <a:off x="1325880" y="5276088"/>
             <a:ext cx="10180015" cy="640080"/>
           </a:xfrm>
           <a:prstGeom prst="roundRect">
@@ -5599,11 +5504,11 @@
             </a:avLst>
           </a:prstGeom>
           <a:solidFill>
-            <a:srgbClr val="DCEDEB"/>
+            <a:srgbClr val="F6F2EC"/>
           </a:solidFill>
           <a:ln w="6350">
             <a:solidFill>
-              <a:srgbClr val="DCEDEB"/>
+              <a:srgbClr val="F6F2EC"/>
             </a:solidFill>
             <a:prstDash val="solid"/>
           </a:ln>
@@ -5624,7 +5529,7 @@
         </p:nvSpPr>
         <p:spPr>
           <a:xfrm>
-            <a:off x="1600200" y="5184648"/>
+            <a:off x="1600200" y="5276088"/>
             <a:ext cx="1828800" cy="640080"/>
           </a:xfrm>
           <a:prstGeom prst="rect">
@@ -5643,7 +5548,7 @@
             <a:r>
               <a:rPr lang="en-US" sz="950" b="1" spc="150" kern="0" dirty="0">
                 <a:solidFill>
-                  <a:srgbClr val="1E8077"/>
+                  <a:srgbClr val="C8652A"/>
                 </a:solidFill>
                 <a:latin typeface="Calibri" pitchFamily="34" charset="0"/>
                 <a:ea typeface="Calibri" pitchFamily="34" charset="-122"/>
@@ -5660,7 +5565,7 @@
             <a:r>
               <a:rPr lang="en-US" sz="1500" b="1" dirty="0">
                 <a:solidFill>
-                  <a:srgbClr val="15202B"/>
+                  <a:srgbClr val="1C2620"/>
                 </a:solidFill>
                 <a:latin typeface="Arial" pitchFamily="34" charset="0"/>
                 <a:ea typeface="Arial" pitchFamily="34" charset="-122"/>
@@ -5680,7 +5585,7 @@
         </p:nvSpPr>
         <p:spPr>
           <a:xfrm>
-            <a:off x="3520440" y="5184648"/>
+            <a:off x="3520440" y="5276088"/>
             <a:ext cx="7711135" cy="640080"/>
           </a:xfrm>
           <a:prstGeom prst="rect">
@@ -5702,7 +5607,7 @@
             <a:r>
               <a:rPr lang="en-US" sz="1150" dirty="0">
                 <a:solidFill>
-                  <a:srgbClr val="5B6670"/>
+                  <a:srgbClr val="5F665F"/>
                 </a:solidFill>
                 <a:latin typeface="Calibri" pitchFamily="34" charset="0"/>
                 <a:ea typeface="Calibri" pitchFamily="34" charset="-122"/>
@@ -5741,13 +5646,13 @@
             <a:r>
               <a:rPr lang="en-US" sz="1000" dirty="0">
                 <a:solidFill>
-                  <a:srgbClr val="5B6670"/>
+                  <a:srgbClr val="5F665F"/>
                 </a:solidFill>
                 <a:latin typeface="Calibri" pitchFamily="34" charset="0"/>
                 <a:ea typeface="Calibri" pitchFamily="34" charset="-122"/>
                 <a:cs typeface="Calibri" pitchFamily="34" charset="-120"/>
               </a:rPr>
-              <a:t>Prepared by Sean</a:t>
+              <a:t>Sean</a:t>
             </a:r>
             <a:endParaRPr lang="en-US" sz="1000" dirty="0"/>
           </a:p>
@@ -5780,7 +5685,7 @@
             <a:r>
               <a:rPr lang="en-US" sz="1000" dirty="0">
                 <a:solidFill>
-                  <a:srgbClr val="5B6670"/>
+                  <a:srgbClr val="5F665F"/>
                 </a:solidFill>
                 <a:latin typeface="Calibri" pitchFamily="34" charset="0"/>
                 <a:ea typeface="Calibri" pitchFamily="34" charset="-122"/>
@@ -5851,13 +5756,13 @@
             <a:r>
               <a:rPr lang="en-US" sz="1200" b="1" spc="200" kern="0" dirty="0">
                 <a:solidFill>
-                  <a:srgbClr val="1E8077"/>
+                  <a:srgbClr val="C8652A"/>
                 </a:solidFill>
                 <a:latin typeface="Calibri" pitchFamily="34" charset="0"/>
                 <a:ea typeface="Calibri" pitchFamily="34" charset="-122"/>
                 <a:cs typeface="Calibri" pitchFamily="34" charset="-120"/>
               </a:rPr>
-              <a:t>04   IMMEDIATE VALIDATION</a:t>
+              <a:t>06   </a:t>
             </a:r>
             <a:endParaRPr lang="en-US" sz="1200" dirty="0"/>
           </a:p>
@@ -5872,7 +5777,7 @@
         <p:spPr>
           <a:xfrm>
             <a:off x="685800" y="768096"/>
-            <a:ext cx="10820095" cy="640080"/>
+            <a:ext cx="10820095" cy="914400"/>
           </a:xfrm>
           <a:prstGeom prst="rect">
             <a:avLst/>
@@ -5890,13 +5795,13 @@
             <a:r>
               <a:rPr lang="en-US" sz="3200" b="1" dirty="0">
                 <a:solidFill>
-                  <a:srgbClr val="15202B"/>
+                  <a:srgbClr val="1C2620"/>
                 </a:solidFill>
                 <a:latin typeface="Arial" pitchFamily="34" charset="0"/>
                 <a:ea typeface="Arial" pitchFamily="34" charset="-122"/>
                 <a:cs typeface="Arial" pitchFamily="34" charset="-120"/>
               </a:rPr>
-              <a:t>Test Carousel</a:t>
+              <a:t>Immediate Validation (Test Carousel)</a:t>
             </a:r>
             <a:endParaRPr lang="en-US" sz="3200" dirty="0"/>
           </a:p>
@@ -5929,7 +5834,7 @@
             <a:r>
               <a:rPr lang="en-US" sz="1300" dirty="0">
                 <a:solidFill>
-                  <a:srgbClr val="5B6670"/>
+                  <a:srgbClr val="5F665F"/>
                 </a:solidFill>
                 <a:latin typeface="Calibri" pitchFamily="34" charset="0"/>
                 <a:ea typeface="Calibri" pitchFamily="34" charset="-122"/>
@@ -5943,77 +5848,26 @@
       </p:sp>
       <p:sp>
         <p:nvSpPr>
-          <p:cNvPr id="5" name="Text 3"/>
-          <p:cNvSpPr txBox="1"/>
+          <p:cNvPr id="5" name="Shape 3"/>
+          <p:cNvSpPr/>
           <p:nvPr/>
         </p:nvSpPr>
         <p:spPr>
           <a:xfrm>
             <a:off x="685800" y="2103120"/>
-            <a:ext cx="3291840" cy="274320"/>
-          </a:xfrm>
-          <a:prstGeom prst="rect">
-            <a:avLst/>
-          </a:prstGeom>
-          <a:noFill/>
-          <a:ln/>
-        </p:spPr>
-        <p:txBody>
-          <a:bodyPr wrap="square" lIns="0" tIns="0" rIns="0" bIns="0" rtlCol="0" anchor="ctr"/>
-          <a:lstStyle/>
-          <a:p>
-            <a:pPr indent="0" marL="0">
-              <a:buNone/>
-            </a:pPr>
-            <a:r>
-              <a:rPr lang="en-US" sz="1100" b="1" spc="200" kern="0" dirty="0">
-                <a:solidFill>
-                  <a:srgbClr val="1E8077"/>
-                </a:solidFill>
-                <a:latin typeface="Calibri" pitchFamily="34" charset="0"/>
-                <a:ea typeface="Calibri" pitchFamily="34" charset="-122"/>
-                <a:cs typeface="Calibri" pitchFamily="34" charset="-120"/>
-              </a:rPr>
-              <a:t>SLIDE 1   </a:t>
-            </a:r>
-            <a:pPr indent="0" marL="0">
-              <a:buNone/>
-            </a:pPr>
-            <a:r>
-              <a:rPr lang="en-US" sz="1100" dirty="0">
-                <a:solidFill>
-                  <a:srgbClr val="5B6670"/>
-                </a:solidFill>
-                <a:latin typeface="Calibri" pitchFamily="34" charset="0"/>
-                <a:ea typeface="Calibri" pitchFamily="34" charset="-122"/>
-                <a:cs typeface="Calibri" pitchFamily="34" charset="-120"/>
-              </a:rPr>
-              <a:t>The Hook</a:t>
-            </a:r>
-            <a:endParaRPr lang="en-US" sz="1100" dirty="0"/>
-          </a:p>
-        </p:txBody>
-      </p:sp>
-      <p:sp>
-        <p:nvSpPr>
-          <p:cNvPr id="6" name="Shape 4"/>
-          <p:cNvSpPr/>
-          <p:nvPr/>
-        </p:nvSpPr>
-        <p:spPr>
-          <a:xfrm>
-            <a:off x="685800" y="2514600"/>
-            <a:ext cx="3291840" cy="3291840"/>
-          </a:xfrm>
-          <a:prstGeom prst="rect">
-            <a:avLst/>
+            <a:ext cx="3423818" cy="3931920"/>
+          </a:xfrm>
+          <a:prstGeom prst="roundRect">
+            <a:avLst>
+              <a:gd name="adj" fmla="val 2404"/>
+            </a:avLst>
           </a:prstGeom>
           <a:solidFill>
-            <a:srgbClr val="000000"/>
+            <a:srgbClr val="F6F2EC"/>
           </a:solidFill>
           <a:ln w="6350">
             <a:solidFill>
-              <a:srgbClr val="000000"/>
+              <a:srgbClr val="F6F2EC"/>
             </a:solidFill>
             <a:prstDash val="solid"/>
           </a:ln>
@@ -6028,14 +5882,39 @@
       </p:sp>
       <p:sp>
         <p:nvSpPr>
+          <p:cNvPr id="6" name="Shape 4"/>
+          <p:cNvSpPr/>
+          <p:nvPr/>
+        </p:nvSpPr>
+        <p:spPr>
+          <a:xfrm>
+            <a:off x="1051560" y="2487168"/>
+            <a:ext cx="420624" cy="420624"/>
+          </a:xfrm>
+          <a:prstGeom prst="ellipse">
+            <a:avLst/>
+          </a:prstGeom>
+          <a:solidFill>
+            <a:srgbClr val="C8652A"/>
+          </a:solidFill>
+          <a:ln w="6350">
+            <a:solidFill>
+              <a:srgbClr val="C8652A"/>
+            </a:solidFill>
+            <a:prstDash val="solid"/>
+          </a:ln>
+        </p:spPr>
+      </p:sp>
+      <p:sp>
+        <p:nvSpPr>
           <p:cNvPr id="7" name="Text 5"/>
           <p:cNvSpPr txBox="1"/>
           <p:nvPr/>
         </p:nvSpPr>
         <p:spPr>
           <a:xfrm>
-            <a:off x="1051560" y="2880360"/>
-            <a:ext cx="2560320" cy="2560320"/>
+            <a:off x="1051560" y="2487168"/>
+            <a:ext cx="420624" cy="420624"/>
           </a:xfrm>
           <a:prstGeom prst="rect">
             <a:avLst/>
@@ -6048,115 +5927,101 @@
           <a:lstStyle/>
           <a:p>
             <a:pPr algn="ctr" indent="0" marL="0">
+              <a:buNone/>
+            </a:pPr>
+            <a:r>
+              <a:rPr lang="en-US" sz="1400" b="1" dirty="0">
+                <a:solidFill>
+                  <a:srgbClr val="FFFFFF"/>
+                </a:solidFill>
+                <a:latin typeface="Arial" pitchFamily="34" charset="0"/>
+                <a:ea typeface="Arial" pitchFamily="34" charset="-122"/>
+                <a:cs typeface="Arial" pitchFamily="34" charset="-120"/>
+              </a:rPr>
+              <a:t>1</a:t>
+            </a:r>
+            <a:endParaRPr lang="en-US" sz="1400" dirty="0"/>
+          </a:p>
+        </p:txBody>
+      </p:sp>
+      <p:sp>
+        <p:nvSpPr>
+          <p:cNvPr id="8" name="Text 6"/>
+          <p:cNvSpPr txBox="1"/>
+          <p:nvPr/>
+        </p:nvSpPr>
+        <p:spPr>
+          <a:xfrm>
+            <a:off x="1051560" y="3127248"/>
+            <a:ext cx="2692298" cy="685800"/>
+          </a:xfrm>
+          <a:prstGeom prst="rect">
+            <a:avLst/>
+          </a:prstGeom>
+          <a:noFill/>
+          <a:ln/>
+        </p:spPr>
+        <p:txBody>
+          <a:bodyPr wrap="square" lIns="0" tIns="0" rIns="0" bIns="0" rtlCol="0" anchor="t"/>
+          <a:lstStyle/>
+          <a:p>
+            <a:pPr indent="0" marL="0">
+              <a:buNone/>
+            </a:pPr>
+            <a:r>
+              <a:rPr lang="en-US" sz="1800" b="1" dirty="0">
+                <a:solidFill>
+                  <a:srgbClr val="1C2620"/>
+                </a:solidFill>
+                <a:latin typeface="Arial" pitchFamily="34" charset="0"/>
+                <a:ea typeface="Arial" pitchFamily="34" charset="-122"/>
+                <a:cs typeface="Arial" pitchFamily="34" charset="-120"/>
+              </a:rPr>
+              <a:t>Slide 1 (The Hook)</a:t>
+            </a:r>
+            <a:endParaRPr lang="en-US" sz="1800" dirty="0"/>
+          </a:p>
+        </p:txBody>
+      </p:sp>
+      <p:sp>
+        <p:nvSpPr>
+          <p:cNvPr id="9" name="Text 7"/>
+          <p:cNvSpPr txBox="1"/>
+          <p:nvPr/>
+        </p:nvSpPr>
+        <p:spPr>
+          <a:xfrm>
+            <a:off x="1051560" y="3886200"/>
+            <a:ext cx="2692298" cy="2103120"/>
+          </a:xfrm>
+          <a:prstGeom prst="rect">
+            <a:avLst/>
+          </a:prstGeom>
+          <a:noFill/>
+          <a:ln/>
+        </p:spPr>
+        <p:txBody>
+          <a:bodyPr wrap="square" lIns="0" tIns="0" rIns="0" bIns="0" rtlCol="0" anchor="t"/>
+          <a:lstStyle/>
+          <a:p>
+            <a:pPr indent="0" marL="0">
               <a:lnSpc>
                 <a:spcPct val="115000"/>
               </a:lnSpc>
               <a:buNone/>
             </a:pPr>
             <a:r>
-              <a:rPr lang="en-US" sz="2000" b="1" dirty="0">
-                <a:solidFill>
-                  <a:srgbClr val="FFFFFF"/>
-                </a:solidFill>
-                <a:latin typeface="Arial" pitchFamily="34" charset="0"/>
-                <a:ea typeface="Arial" pitchFamily="34" charset="-122"/>
-                <a:cs typeface="Arial" pitchFamily="34" charset="-120"/>
-              </a:rPr>
-              <a:t>You stretch every single day. And your hips are just as tight as they were six months ago.</a:t>
-            </a:r>
-            <a:endParaRPr lang="en-US" sz="2000" dirty="0"/>
-          </a:p>
-        </p:txBody>
-      </p:sp>
-      <p:sp>
-        <p:nvSpPr>
-          <p:cNvPr id="8" name="Text 6"/>
-          <p:cNvSpPr txBox="1"/>
-          <p:nvPr/>
-        </p:nvSpPr>
-        <p:spPr>
-          <a:xfrm>
-            <a:off x="3337560" y="5422392"/>
-            <a:ext cx="457200" cy="228600"/>
-          </a:xfrm>
-          <a:prstGeom prst="rect">
-            <a:avLst/>
-          </a:prstGeom>
-          <a:noFill/>
-          <a:ln/>
-        </p:spPr>
-        <p:txBody>
-          <a:bodyPr wrap="square" lIns="0" tIns="0" rIns="0" bIns="0" rtlCol="0" anchor="ctr"/>
-          <a:lstStyle/>
-          <a:p>
-            <a:pPr algn="r" indent="0" marL="0">
-              <a:buNone/>
-            </a:pPr>
-            <a:r>
-              <a:rPr lang="en-US" sz="900" dirty="0">
-                <a:solidFill>
-                  <a:srgbClr val="8A8A8A"/>
+              <a:rPr lang="en-US" sz="1300" dirty="0">
+                <a:solidFill>
+                  <a:srgbClr val="5F665F"/>
                 </a:solidFill>
                 <a:latin typeface="Calibri" pitchFamily="34" charset="0"/>
                 <a:ea typeface="Calibri" pitchFamily="34" charset="-122"/>
                 <a:cs typeface="Calibri" pitchFamily="34" charset="-120"/>
               </a:rPr>
-              <a:t>1/3</a:t>
-            </a:r>
-            <a:endParaRPr lang="en-US" sz="900" dirty="0"/>
-          </a:p>
-        </p:txBody>
-      </p:sp>
-      <p:sp>
-        <p:nvSpPr>
-          <p:cNvPr id="9" name="Text 7"/>
-          <p:cNvSpPr txBox="1"/>
-          <p:nvPr/>
-        </p:nvSpPr>
-        <p:spPr>
-          <a:xfrm>
-            <a:off x="4449928" y="2103120"/>
-            <a:ext cx="3291840" cy="274320"/>
-          </a:xfrm>
-          <a:prstGeom prst="rect">
-            <a:avLst/>
-          </a:prstGeom>
-          <a:noFill/>
-          <a:ln/>
-        </p:spPr>
-        <p:txBody>
-          <a:bodyPr wrap="square" lIns="0" tIns="0" rIns="0" bIns="0" rtlCol="0" anchor="ctr"/>
-          <a:lstStyle/>
-          <a:p>
-            <a:pPr indent="0" marL="0">
-              <a:buNone/>
-            </a:pPr>
-            <a:r>
-              <a:rPr lang="en-US" sz="1100" b="1" spc="200" kern="0" dirty="0">
-                <a:solidFill>
-                  <a:srgbClr val="1E8077"/>
-                </a:solidFill>
-                <a:latin typeface="Calibri" pitchFamily="34" charset="0"/>
-                <a:ea typeface="Calibri" pitchFamily="34" charset="-122"/>
-                <a:cs typeface="Calibri" pitchFamily="34" charset="-120"/>
-              </a:rPr>
-              <a:t>SLIDE 2   </a:t>
-            </a:r>
-            <a:pPr indent="0" marL="0">
-              <a:buNone/>
-            </a:pPr>
-            <a:r>
-              <a:rPr lang="en-US" sz="1100" dirty="0">
-                <a:solidFill>
-                  <a:srgbClr val="5B6670"/>
-                </a:solidFill>
-                <a:latin typeface="Calibri" pitchFamily="34" charset="0"/>
-                <a:ea typeface="Calibri" pitchFamily="34" charset="-122"/>
-                <a:cs typeface="Calibri" pitchFamily="34" charset="-120"/>
-              </a:rPr>
-              <a:t>The Agitation</a:t>
-            </a:r>
-            <a:endParaRPr lang="en-US" sz="1100" dirty="0"/>
+              <a:t>You stretch every single day. And your hips are just as tight as they were six months ago.</a:t>
+            </a:r>
+            <a:endParaRPr lang="en-US" sz="1300" dirty="0"/>
           </a:p>
         </p:txBody>
       </p:sp>
@@ -6168,18 +6033,20 @@
         </p:nvSpPr>
         <p:spPr>
           <a:xfrm>
-            <a:off x="4449928" y="2514600"/>
-            <a:ext cx="3291840" cy="3291840"/>
-          </a:xfrm>
-          <a:prstGeom prst="rect">
-            <a:avLst/>
+            <a:off x="4383938" y="2103120"/>
+            <a:ext cx="3423818" cy="3931920"/>
+          </a:xfrm>
+          <a:prstGeom prst="roundRect">
+            <a:avLst>
+              <a:gd name="adj" fmla="val 2404"/>
+            </a:avLst>
           </a:prstGeom>
           <a:solidFill>
-            <a:srgbClr val="000000"/>
+            <a:srgbClr val="F6F2EC"/>
           </a:solidFill>
           <a:ln w="6350">
             <a:solidFill>
-              <a:srgbClr val="000000"/>
+              <a:srgbClr val="F6F2EC"/>
             </a:solidFill>
             <a:prstDash val="solid"/>
           </a:ln>
@@ -6194,14 +6061,39 @@
       </p:sp>
       <p:sp>
         <p:nvSpPr>
-          <p:cNvPr id="11" name="Text 9"/>
-          <p:cNvSpPr txBox="1"/>
-          <p:nvPr/>
-        </p:nvSpPr>
-        <p:spPr>
-          <a:xfrm>
-            <a:off x="4815688" y="2880360"/>
-            <a:ext cx="2560320" cy="2560320"/>
+          <p:cNvPr id="11" name="Shape 9"/>
+          <p:cNvSpPr/>
+          <p:nvPr/>
+        </p:nvSpPr>
+        <p:spPr>
+          <a:xfrm>
+            <a:off x="4749698" y="2487168"/>
+            <a:ext cx="420624" cy="420624"/>
+          </a:xfrm>
+          <a:prstGeom prst="ellipse">
+            <a:avLst/>
+          </a:prstGeom>
+          <a:solidFill>
+            <a:srgbClr val="C8652A"/>
+          </a:solidFill>
+          <a:ln w="6350">
+            <a:solidFill>
+              <a:srgbClr val="C8652A"/>
+            </a:solidFill>
+            <a:prstDash val="solid"/>
+          </a:ln>
+        </p:spPr>
+      </p:sp>
+      <p:sp>
+        <p:nvSpPr>
+          <p:cNvPr id="12" name="Text 10"/>
+          <p:cNvSpPr txBox="1"/>
+          <p:nvPr/>
+        </p:nvSpPr>
+        <p:spPr>
+          <a:xfrm>
+            <a:off x="4749698" y="2487168"/>
+            <a:ext cx="420624" cy="420624"/>
           </a:xfrm>
           <a:prstGeom prst="rect">
             <a:avLst/>
@@ -6214,138 +6106,126 @@
           <a:lstStyle/>
           <a:p>
             <a:pPr algn="ctr" indent="0" marL="0">
+              <a:buNone/>
+            </a:pPr>
+            <a:r>
+              <a:rPr lang="en-US" sz="1400" b="1" dirty="0">
+                <a:solidFill>
+                  <a:srgbClr val="FFFFFF"/>
+                </a:solidFill>
+                <a:latin typeface="Arial" pitchFamily="34" charset="0"/>
+                <a:ea typeface="Arial" pitchFamily="34" charset="-122"/>
+                <a:cs typeface="Arial" pitchFamily="34" charset="-120"/>
+              </a:rPr>
+              <a:t>2</a:t>
+            </a:r>
+            <a:endParaRPr lang="en-US" sz="1400" dirty="0"/>
+          </a:p>
+        </p:txBody>
+      </p:sp>
+      <p:sp>
+        <p:nvSpPr>
+          <p:cNvPr id="13" name="Text 11"/>
+          <p:cNvSpPr txBox="1"/>
+          <p:nvPr/>
+        </p:nvSpPr>
+        <p:spPr>
+          <a:xfrm>
+            <a:off x="4749698" y="3127248"/>
+            <a:ext cx="2692298" cy="685800"/>
+          </a:xfrm>
+          <a:prstGeom prst="rect">
+            <a:avLst/>
+          </a:prstGeom>
+          <a:noFill/>
+          <a:ln/>
+        </p:spPr>
+        <p:txBody>
+          <a:bodyPr wrap="square" lIns="0" tIns="0" rIns="0" bIns="0" rtlCol="0" anchor="t"/>
+          <a:lstStyle/>
+          <a:p>
+            <a:pPr indent="0" marL="0">
+              <a:buNone/>
+            </a:pPr>
+            <a:r>
+              <a:rPr lang="en-US" sz="1800" b="1" dirty="0">
+                <a:solidFill>
+                  <a:srgbClr val="1C2620"/>
+                </a:solidFill>
+                <a:latin typeface="Arial" pitchFamily="34" charset="0"/>
+                <a:ea typeface="Arial" pitchFamily="34" charset="-122"/>
+                <a:cs typeface="Arial" pitchFamily="34" charset="-120"/>
+              </a:rPr>
+              <a:t>Slide 2 (The Agitation)</a:t>
+            </a:r>
+            <a:endParaRPr lang="en-US" sz="1800" dirty="0"/>
+          </a:p>
+        </p:txBody>
+      </p:sp>
+      <p:sp>
+        <p:nvSpPr>
+          <p:cNvPr id="14" name="Text 12"/>
+          <p:cNvSpPr txBox="1"/>
+          <p:nvPr/>
+        </p:nvSpPr>
+        <p:spPr>
+          <a:xfrm>
+            <a:off x="4749698" y="3886200"/>
+            <a:ext cx="2692298" cy="2103120"/>
+          </a:xfrm>
+          <a:prstGeom prst="rect">
+            <a:avLst/>
+          </a:prstGeom>
+          <a:noFill/>
+          <a:ln/>
+        </p:spPr>
+        <p:txBody>
+          <a:bodyPr wrap="square" lIns="0" tIns="0" rIns="0" bIns="0" rtlCol="0" anchor="t"/>
+          <a:lstStyle/>
+          <a:p>
+            <a:pPr indent="0" marL="0">
               <a:lnSpc>
                 <a:spcPct val="115000"/>
               </a:lnSpc>
               <a:buNone/>
             </a:pPr>
             <a:r>
-              <a:rPr lang="en-US" sz="1450" b="1" dirty="0">
-                <a:solidFill>
-                  <a:srgbClr val="FFFFFF"/>
-                </a:solidFill>
-                <a:latin typeface="Arial" pitchFamily="34" charset="0"/>
-                <a:ea typeface="Arial" pitchFamily="34" charset="-122"/>
-                <a:cs typeface="Arial" pitchFamily="34" charset="-120"/>
-              </a:rPr>
-              <a:t>It is not your muscles refusing to open. It is your nervous system slamming on the brakes because it feels zero control in those end ranges. Pushing harder only makes your body fight you back.</a:t>
-            </a:r>
-            <a:endParaRPr lang="en-US" sz="1450" dirty="0"/>
-          </a:p>
-        </p:txBody>
-      </p:sp>
-      <p:sp>
-        <p:nvSpPr>
-          <p:cNvPr id="12" name="Text 10"/>
-          <p:cNvSpPr txBox="1"/>
-          <p:nvPr/>
-        </p:nvSpPr>
-        <p:spPr>
-          <a:xfrm>
-            <a:off x="7101688" y="5422392"/>
-            <a:ext cx="457200" cy="228600"/>
-          </a:xfrm>
-          <a:prstGeom prst="rect">
-            <a:avLst/>
-          </a:prstGeom>
-          <a:noFill/>
-          <a:ln/>
-        </p:spPr>
-        <p:txBody>
-          <a:bodyPr wrap="square" lIns="0" tIns="0" rIns="0" bIns="0" rtlCol="0" anchor="ctr"/>
-          <a:lstStyle/>
-          <a:p>
-            <a:pPr algn="r" indent="0" marL="0">
-              <a:buNone/>
-            </a:pPr>
-            <a:r>
-              <a:rPr lang="en-US" sz="900" dirty="0">
-                <a:solidFill>
-                  <a:srgbClr val="8A8A8A"/>
+              <a:rPr lang="en-US" sz="1300" dirty="0">
+                <a:solidFill>
+                  <a:srgbClr val="5F665F"/>
                 </a:solidFill>
                 <a:latin typeface="Calibri" pitchFamily="34" charset="0"/>
                 <a:ea typeface="Calibri" pitchFamily="34" charset="-122"/>
                 <a:cs typeface="Calibri" pitchFamily="34" charset="-120"/>
               </a:rPr>
-              <a:t>2/3</a:t>
-            </a:r>
-            <a:endParaRPr lang="en-US" sz="900" dirty="0"/>
-          </a:p>
-        </p:txBody>
-      </p:sp>
-      <p:sp>
-        <p:nvSpPr>
-          <p:cNvPr id="13" name="Text 11"/>
-          <p:cNvSpPr txBox="1"/>
-          <p:nvPr/>
-        </p:nvSpPr>
-        <p:spPr>
-          <a:xfrm>
-            <a:off x="8214055" y="2103120"/>
-            <a:ext cx="3291840" cy="274320"/>
-          </a:xfrm>
-          <a:prstGeom prst="rect">
-            <a:avLst/>
-          </a:prstGeom>
-          <a:noFill/>
-          <a:ln/>
-        </p:spPr>
-        <p:txBody>
-          <a:bodyPr wrap="square" lIns="0" tIns="0" rIns="0" bIns="0" rtlCol="0" anchor="ctr"/>
-          <a:lstStyle/>
-          <a:p>
-            <a:pPr indent="0" marL="0">
-              <a:buNone/>
-            </a:pPr>
-            <a:r>
-              <a:rPr lang="en-US" sz="1100" b="1" spc="200" kern="0" dirty="0">
-                <a:solidFill>
-                  <a:srgbClr val="1E8077"/>
-                </a:solidFill>
-                <a:latin typeface="Calibri" pitchFamily="34" charset="0"/>
-                <a:ea typeface="Calibri" pitchFamily="34" charset="-122"/>
-                <a:cs typeface="Calibri" pitchFamily="34" charset="-120"/>
-              </a:rPr>
-              <a:t>SLIDE 3   </a:t>
-            </a:r>
-            <a:pPr indent="0" marL="0">
-              <a:buNone/>
-            </a:pPr>
-            <a:r>
-              <a:rPr lang="en-US" sz="1100" dirty="0">
-                <a:solidFill>
-                  <a:srgbClr val="5B6670"/>
-                </a:solidFill>
-                <a:latin typeface="Calibri" pitchFamily="34" charset="0"/>
-                <a:ea typeface="Calibri" pitchFamily="34" charset="-122"/>
-                <a:cs typeface="Calibri" pitchFamily="34" charset="-120"/>
-              </a:rPr>
-              <a:t>Curiosity / Call to Action</a:t>
-            </a:r>
-            <a:endParaRPr lang="en-US" sz="1100" dirty="0"/>
-          </a:p>
-        </p:txBody>
-      </p:sp>
-      <p:sp>
-        <p:nvSpPr>
-          <p:cNvPr id="14" name="Shape 12"/>
+              <a:t>It is not your muscles refusing to open. It is your nervous system slamming on the brakes because it feels zero control in those end ranges. Pushing harder only makes your body fight you back.</a:t>
+            </a:r>
+            <a:endParaRPr lang="en-US" sz="1300" dirty="0"/>
+          </a:p>
+        </p:txBody>
+      </p:sp>
+      <p:sp>
+        <p:nvSpPr>
+          <p:cNvPr id="15" name="Shape 13"/>
           <p:cNvSpPr/>
           <p:nvPr/>
         </p:nvSpPr>
         <p:spPr>
           <a:xfrm>
-            <a:off x="8214055" y="2514600"/>
-            <a:ext cx="3291840" cy="3291840"/>
-          </a:xfrm>
-          <a:prstGeom prst="rect">
-            <a:avLst/>
+            <a:off x="8082077" y="2103120"/>
+            <a:ext cx="3423818" cy="3931920"/>
+          </a:xfrm>
+          <a:prstGeom prst="roundRect">
+            <a:avLst>
+              <a:gd name="adj" fmla="val 2404"/>
+            </a:avLst>
           </a:prstGeom>
           <a:solidFill>
-            <a:srgbClr val="000000"/>
+            <a:srgbClr val="1C2620"/>
           </a:solidFill>
           <a:ln w="6350">
             <a:solidFill>
-              <a:srgbClr val="000000"/>
+              <a:srgbClr val="1C2620"/>
             </a:solidFill>
             <a:prstDash val="solid"/>
           </a:ln>
@@ -6360,14 +6240,39 @@
       </p:sp>
       <p:sp>
         <p:nvSpPr>
-          <p:cNvPr id="15" name="Text 13"/>
-          <p:cNvSpPr txBox="1"/>
-          <p:nvPr/>
-        </p:nvSpPr>
-        <p:spPr>
-          <a:xfrm>
-            <a:off x="8579815" y="2880360"/>
-            <a:ext cx="2560320" cy="2560320"/>
+          <p:cNvPr id="16" name="Shape 14"/>
+          <p:cNvSpPr/>
+          <p:nvPr/>
+        </p:nvSpPr>
+        <p:spPr>
+          <a:xfrm>
+            <a:off x="8447837" y="2487168"/>
+            <a:ext cx="420624" cy="420624"/>
+          </a:xfrm>
+          <a:prstGeom prst="ellipse">
+            <a:avLst/>
+          </a:prstGeom>
+          <a:solidFill>
+            <a:srgbClr val="C8652A"/>
+          </a:solidFill>
+          <a:ln w="6350">
+            <a:solidFill>
+              <a:srgbClr val="C8652A"/>
+            </a:solidFill>
+            <a:prstDash val="solid"/>
+          </a:ln>
+        </p:spPr>
+      </p:sp>
+      <p:sp>
+        <p:nvSpPr>
+          <p:cNvPr id="17" name="Text 15"/>
+          <p:cNvSpPr txBox="1"/>
+          <p:nvPr/>
+        </p:nvSpPr>
+        <p:spPr>
+          <a:xfrm>
+            <a:off x="8447837" y="2487168"/>
+            <a:ext cx="420624" cy="420624"/>
           </a:xfrm>
           <a:prstGeom prst="rect">
             <a:avLst/>
@@ -6380,97 +6285,107 @@
           <a:lstStyle/>
           <a:p>
             <a:pPr algn="ctr" indent="0" marL="0">
+              <a:buNone/>
+            </a:pPr>
+            <a:r>
+              <a:rPr lang="en-US" sz="1400" b="1" dirty="0">
+                <a:solidFill>
+                  <a:srgbClr val="FFFFFF"/>
+                </a:solidFill>
+                <a:latin typeface="Arial" pitchFamily="34" charset="0"/>
+                <a:ea typeface="Arial" pitchFamily="34" charset="-122"/>
+                <a:cs typeface="Arial" pitchFamily="34" charset="-120"/>
+              </a:rPr>
+              <a:t>3</a:t>
+            </a:r>
+            <a:endParaRPr lang="en-US" sz="1400" dirty="0"/>
+          </a:p>
+        </p:txBody>
+      </p:sp>
+      <p:sp>
+        <p:nvSpPr>
+          <p:cNvPr id="18" name="Text 16"/>
+          <p:cNvSpPr txBox="1"/>
+          <p:nvPr/>
+        </p:nvSpPr>
+        <p:spPr>
+          <a:xfrm>
+            <a:off x="8447837" y="3127248"/>
+            <a:ext cx="2692298" cy="685800"/>
+          </a:xfrm>
+          <a:prstGeom prst="rect">
+            <a:avLst/>
+          </a:prstGeom>
+          <a:noFill/>
+          <a:ln/>
+        </p:spPr>
+        <p:txBody>
+          <a:bodyPr wrap="square" lIns="0" tIns="0" rIns="0" bIns="0" rtlCol="0" anchor="t"/>
+          <a:lstStyle/>
+          <a:p>
+            <a:pPr indent="0" marL="0">
+              <a:buNone/>
+            </a:pPr>
+            <a:r>
+              <a:rPr lang="en-US" sz="1800" b="1" dirty="0">
+                <a:solidFill>
+                  <a:srgbClr val="FFFFFF"/>
+                </a:solidFill>
+                <a:latin typeface="Arial" pitchFamily="34" charset="0"/>
+                <a:ea typeface="Arial" pitchFamily="34" charset="-122"/>
+                <a:cs typeface="Arial" pitchFamily="34" charset="-120"/>
+              </a:rPr>
+              <a:t>Slide 3 (Curiosity/Call to Action)</a:t>
+            </a:r>
+            <a:endParaRPr lang="en-US" sz="1800" dirty="0"/>
+          </a:p>
+        </p:txBody>
+      </p:sp>
+      <p:sp>
+        <p:nvSpPr>
+          <p:cNvPr id="19" name="Text 17"/>
+          <p:cNvSpPr txBox="1"/>
+          <p:nvPr/>
+        </p:nvSpPr>
+        <p:spPr>
+          <a:xfrm>
+            <a:off x="8447837" y="3886200"/>
+            <a:ext cx="2692298" cy="2103120"/>
+          </a:xfrm>
+          <a:prstGeom prst="rect">
+            <a:avLst/>
+          </a:prstGeom>
+          <a:noFill/>
+          <a:ln/>
+        </p:spPr>
+        <p:txBody>
+          <a:bodyPr wrap="square" lIns="0" tIns="0" rIns="0" bIns="0" rtlCol="0" anchor="t"/>
+          <a:lstStyle/>
+          <a:p>
+            <a:pPr indent="0" marL="0">
               <a:lnSpc>
                 <a:spcPct val="115000"/>
               </a:lnSpc>
               <a:buNone/>
             </a:pPr>
             <a:r>
-              <a:rPr lang="en-US" sz="1600" b="1" dirty="0">
-                <a:solidFill>
-                  <a:srgbClr val="FFFFFF"/>
-                </a:solidFill>
-                <a:latin typeface="Arial" pitchFamily="34" charset="0"/>
-                <a:ea typeface="Arial" pitchFamily="34" charset="-122"/>
-                <a:cs typeface="Arial" pitchFamily="34" charset="-120"/>
-              </a:rPr>
-              <a:t>What if you stopped forcing stretches and started retraining how your brain perceives end-range stability?</a:t>
-            </a:r>
-            <a:endParaRPr lang="en-US" sz="1600" dirty="0"/>
-          </a:p>
-          <a:p>
-            <a:pPr algn="ctr" indent="0" marL="0">
-              <a:lnSpc>
-                <a:spcPct val="115000"/>
-              </a:lnSpc>
-              <a:buNone/>
-            </a:pPr>
-            <a:endParaRPr lang="en-US" sz="1600" dirty="0"/>
-          </a:p>
-          <a:p>
-            <a:pPr algn="ctr" indent="0" marL="0">
-              <a:lnSpc>
-                <a:spcPct val="115000"/>
-              </a:lnSpc>
-              <a:buNone/>
-            </a:pPr>
-            <a:r>
-              <a:rPr lang="en-US" sz="1600" b="1" dirty="0">
-                <a:solidFill>
-                  <a:srgbClr val="FFFFFF"/>
-                </a:solidFill>
-                <a:latin typeface="Arial" pitchFamily="34" charset="0"/>
-                <a:ea typeface="Arial" pitchFamily="34" charset="-122"/>
-                <a:cs typeface="Arial" pitchFamily="34" charset="-120"/>
-              </a:rPr>
-              <a:t>Reply 'I WANT' if this resonates with you.</a:t>
-            </a:r>
-            <a:endParaRPr lang="en-US" sz="1600" dirty="0"/>
-          </a:p>
-        </p:txBody>
-      </p:sp>
-      <p:sp>
-        <p:nvSpPr>
-          <p:cNvPr id="16" name="Text 14"/>
-          <p:cNvSpPr txBox="1"/>
-          <p:nvPr/>
-        </p:nvSpPr>
-        <p:spPr>
-          <a:xfrm>
-            <a:off x="10865815" y="5422392"/>
-            <a:ext cx="457200" cy="228600"/>
-          </a:xfrm>
-          <a:prstGeom prst="rect">
-            <a:avLst/>
-          </a:prstGeom>
-          <a:noFill/>
-          <a:ln/>
-        </p:spPr>
-        <p:txBody>
-          <a:bodyPr wrap="square" lIns="0" tIns="0" rIns="0" bIns="0" rtlCol="0" anchor="ctr"/>
-          <a:lstStyle/>
-          <a:p>
-            <a:pPr algn="r" indent="0" marL="0">
-              <a:buNone/>
-            </a:pPr>
-            <a:r>
-              <a:rPr lang="en-US" sz="900" dirty="0">
-                <a:solidFill>
-                  <a:srgbClr val="8A8A8A"/>
+              <a:rPr lang="en-US" sz="1300" dirty="0">
+                <a:solidFill>
+                  <a:srgbClr val="AEB8AF"/>
                 </a:solidFill>
                 <a:latin typeface="Calibri" pitchFamily="34" charset="0"/>
                 <a:ea typeface="Calibri" pitchFamily="34" charset="-122"/>
                 <a:cs typeface="Calibri" pitchFamily="34" charset="-120"/>
               </a:rPr>
-              <a:t>3/3</a:t>
-            </a:r>
-            <a:endParaRPr lang="en-US" sz="900" dirty="0"/>
-          </a:p>
-        </p:txBody>
-      </p:sp>
-      <p:sp>
-        <p:nvSpPr>
-          <p:cNvPr id="17" name="Text 15"/>
+              <a:t>What if you stopped forcing stretches and started retraining how your brain perceives end-range stability? Reply 'I WANT' if this resonates with you.</a:t>
+            </a:r>
+            <a:endParaRPr lang="en-US" sz="1300" dirty="0"/>
+          </a:p>
+        </p:txBody>
+      </p:sp>
+      <p:sp>
+        <p:nvSpPr>
+          <p:cNvPr id="20" name="Text 18"/>
           <p:cNvSpPr txBox="1"/>
           <p:nvPr/>
         </p:nvSpPr>
@@ -6495,13 +6410,13 @@
             <a:r>
               <a:rPr lang="en-US" sz="1000" dirty="0">
                 <a:solidFill>
-                  <a:srgbClr val="5B6670"/>
+                  <a:srgbClr val="5F665F"/>
                 </a:solidFill>
                 <a:latin typeface="Calibri" pitchFamily="34" charset="0"/>
                 <a:ea typeface="Calibri" pitchFamily="34" charset="-122"/>
                 <a:cs typeface="Calibri" pitchFamily="34" charset="-120"/>
               </a:rPr>
-              <a:t>Prepared by Sean</a:t>
+              <a:t>Sean</a:t>
             </a:r>
             <a:endParaRPr lang="en-US" sz="1000" dirty="0"/>
           </a:p>
@@ -6509,7 +6424,7 @@
       </p:sp>
       <p:sp>
         <p:nvSpPr>
-          <p:cNvPr id="18" name="Text 16"/>
+          <p:cNvPr id="21" name="Text 19"/>
           <p:cNvSpPr txBox="1"/>
           <p:nvPr/>
         </p:nvSpPr>
@@ -6534,7 +6449,7 @@
             <a:r>
               <a:rPr lang="en-US" sz="1000" dirty="0">
                 <a:solidFill>
-                  <a:srgbClr val="5B6670"/>
+                  <a:srgbClr val="5F665F"/>
                 </a:solidFill>
                 <a:latin typeface="Calibri" pitchFamily="34" charset="0"/>
                 <a:ea typeface="Calibri" pitchFamily="34" charset="-122"/>

</xml_diff>